<commit_message>
Add Frontline Club slide with photo (2 April 2026)
New dedicated slide 8 for the Frontline Club London panel
"Human Rights in a Fragmenting World" — full-bleed photo with
Core-coloured left panel. Comms tile on slide 9 ("Other significant
work") corrected: Mary-Anne's "FC convening late May" was post-
production for this event, not a separate convening. 11 slides total.
Refs CAP-199.

Co-Authored-By: Claude Opus 4.7 (1M context) <noreply@anthropic.com>
Co-authored-by: multica-agent <github@multica.ai>
</commit_message>
<xml_diff>
--- a/2026/Q2/08-ED-Operations-Impact-Y2D.pptx
+++ b/2026/Q2/08-ED-Operations-Impact-Y2D.pptx
@@ -15,6 +15,7 @@
     <p:sldId id="263" r:id="rId14"/>
     <p:sldId id="264" r:id="rId15"/>
     <p:sldId id="265" r:id="rId16"/>
+    <p:sldId id="266" r:id="rId17"/>
   </p:sldIdLst>
   <p:sldSz cx="12191695" cy="6858000" type="screen4x3"/>
   <p:notesSz cx="6858000" cy="9144000"/>
@@ -3451,6 +3452,877 @@
             <a:avLst/>
           </a:prstGeom>
           <a:solidFill>
+            <a:srgbClr val="FFFFFF"/>
+          </a:solidFill>
+          <a:ln>
+            <a:noFill/>
+          </a:ln>
+        </p:spPr>
+        <p:style>
+          <a:lnRef idx="1">
+            <a:schemeClr val="accent1"/>
+          </a:lnRef>
+          <a:fillRef idx="3">
+            <a:schemeClr val="accent1"/>
+          </a:fillRef>
+          <a:effectRef idx="2">
+            <a:schemeClr val="accent1"/>
+          </a:effectRef>
+          <a:fontRef idx="minor">
+            <a:schemeClr val="lt1"/>
+          </a:fontRef>
+        </p:style>
+        <p:txBody>
+          <a:bodyPr rtlCol="0" anchor="ctr"/>
+          <a:lstStyle/>
+          <a:p>
+            <a:pPr algn="ctr"/>
+          </a:p>
+        </p:txBody>
+      </p:sp>
+      <p:sp>
+        <p:nvSpPr>
+          <p:cNvPr id="3" name="TextBox 2"/>
+          <p:cNvSpPr txBox="1"/>
+          <p:nvPr/>
+        </p:nvSpPr>
+        <p:spPr>
+          <a:xfrm>
+            <a:off x="640080" y="502920"/>
+            <a:ext cx="10972800" cy="548640"/>
+          </a:xfrm>
+          <a:prstGeom prst="rect">
+            <a:avLst/>
+          </a:prstGeom>
+          <a:noFill/>
+        </p:spPr>
+        <p:txBody>
+          <a:bodyPr wrap="square" anchor="t" lIns="0" rIns="0" tIns="0" bIns="0">
+            <a:spAutoFit/>
+          </a:bodyPr>
+          <a:lstStyle/>
+          <a:p>
+            <a:pPr algn="l">
+              <a:lnSpc>
+                <a:spcPct val="115000"/>
+              </a:lnSpc>
+            </a:pPr>
+            <a:r>
+              <a:rPr sz="2800" b="1" i="0">
+                <a:solidFill>
+                  <a:srgbClr val="410F37"/>
+                </a:solidFill>
+                <a:latin typeface="Inter"/>
+              </a:rPr>
+              <a:t>Strategic outlook and watch-items</a:t>
+            </a:r>
+          </a:p>
+        </p:txBody>
+      </p:sp>
+      <p:sp>
+        <p:nvSpPr>
+          <p:cNvPr id="4" name="Rectangle 3"/>
+          <p:cNvSpPr/>
+          <p:nvPr/>
+        </p:nvSpPr>
+        <p:spPr>
+          <a:xfrm>
+            <a:off x="640080" y="1097280"/>
+            <a:ext cx="548640" cy="54864"/>
+          </a:xfrm>
+          <a:prstGeom prst="rect">
+            <a:avLst/>
+          </a:prstGeom>
+          <a:solidFill>
+            <a:srgbClr val="E12D64"/>
+          </a:solidFill>
+          <a:ln>
+            <a:noFill/>
+          </a:ln>
+          <a:effectLst/>
+        </p:spPr>
+        <p:style>
+          <a:lnRef idx="1">
+            <a:schemeClr val="accent1"/>
+          </a:lnRef>
+          <a:fillRef idx="3">
+            <a:schemeClr val="accent1"/>
+          </a:fillRef>
+          <a:effectRef idx="2">
+            <a:schemeClr val="accent1"/>
+          </a:effectRef>
+          <a:fontRef idx="minor">
+            <a:schemeClr val="lt1"/>
+          </a:fontRef>
+        </p:style>
+        <p:txBody>
+          <a:bodyPr rtlCol="0" anchor="ctr"/>
+          <a:lstStyle/>
+          <a:p>
+            <a:pPr algn="ctr"/>
+          </a:p>
+        </p:txBody>
+      </p:sp>
+      <p:sp>
+        <p:nvSpPr>
+          <p:cNvPr id="5" name="TextBox 4"/>
+          <p:cNvSpPr txBox="1"/>
+          <p:nvPr/>
+        </p:nvSpPr>
+        <p:spPr>
+          <a:xfrm>
+            <a:off x="640080" y="1280160"/>
+            <a:ext cx="10972800" cy="457200"/>
+          </a:xfrm>
+          <a:prstGeom prst="rect">
+            <a:avLst/>
+          </a:prstGeom>
+          <a:noFill/>
+        </p:spPr>
+        <p:txBody>
+          <a:bodyPr wrap="square" anchor="t" lIns="0" rIns="0" tIns="0" bIns="0">
+            <a:spAutoFit/>
+          </a:bodyPr>
+          <a:lstStyle/>
+          <a:p>
+            <a:pPr algn="l">
+              <a:lnSpc>
+                <a:spcPct val="115000"/>
+              </a:lnSpc>
+            </a:pPr>
+            <a:r>
+              <a:rPr sz="1300" b="0" i="1">
+                <a:solidFill>
+                  <a:srgbClr val="E12D64"/>
+                </a:solidFill>
+                <a:latin typeface="Inter"/>
+              </a:rPr>
+              <a:t>Things to keep in view between now and the Q3 meeting.</a:t>
+            </a:r>
+          </a:p>
+        </p:txBody>
+      </p:sp>
+      <p:sp>
+        <p:nvSpPr>
+          <p:cNvPr id="6" name="Rectangle 5"/>
+          <p:cNvSpPr/>
+          <p:nvPr/>
+        </p:nvSpPr>
+        <p:spPr>
+          <a:xfrm>
+            <a:off x="640080" y="1828800"/>
+            <a:ext cx="137160" cy="777240"/>
+          </a:xfrm>
+          <a:prstGeom prst="rect">
+            <a:avLst/>
+          </a:prstGeom>
+          <a:solidFill>
+            <a:srgbClr val="E12D64"/>
+          </a:solidFill>
+          <a:ln>
+            <a:noFill/>
+          </a:ln>
+          <a:effectLst/>
+        </p:spPr>
+        <p:style>
+          <a:lnRef idx="1">
+            <a:schemeClr val="accent1"/>
+          </a:lnRef>
+          <a:fillRef idx="3">
+            <a:schemeClr val="accent1"/>
+          </a:fillRef>
+          <a:effectRef idx="2">
+            <a:schemeClr val="accent1"/>
+          </a:effectRef>
+          <a:fontRef idx="minor">
+            <a:schemeClr val="lt1"/>
+          </a:fontRef>
+        </p:style>
+        <p:txBody>
+          <a:bodyPr rtlCol="0" anchor="ctr"/>
+          <a:lstStyle/>
+          <a:p>
+            <a:pPr algn="ctr"/>
+          </a:p>
+        </p:txBody>
+      </p:sp>
+      <p:sp>
+        <p:nvSpPr>
+          <p:cNvPr id="7" name="TextBox 6"/>
+          <p:cNvSpPr txBox="1"/>
+          <p:nvPr/>
+        </p:nvSpPr>
+        <p:spPr>
+          <a:xfrm>
+            <a:off x="914400" y="1828800"/>
+            <a:ext cx="10698480" cy="365760"/>
+          </a:xfrm>
+          <a:prstGeom prst="rect">
+            <a:avLst/>
+          </a:prstGeom>
+          <a:noFill/>
+        </p:spPr>
+        <p:txBody>
+          <a:bodyPr wrap="square" anchor="t" lIns="0" rIns="0" tIns="0" bIns="0">
+            <a:spAutoFit/>
+          </a:bodyPr>
+          <a:lstStyle/>
+          <a:p>
+            <a:pPr algn="l">
+              <a:lnSpc>
+                <a:spcPct val="115000"/>
+              </a:lnSpc>
+            </a:pPr>
+            <a:r>
+              <a:rPr sz="1300" b="1" i="0">
+                <a:solidFill>
+                  <a:srgbClr val="410F37"/>
+                </a:solidFill>
+                <a:latin typeface="Inter"/>
+              </a:rPr>
+              <a:t>Reserves and deficit-model donors</a:t>
+            </a:r>
+          </a:p>
+        </p:txBody>
+      </p:sp>
+      <p:sp>
+        <p:nvSpPr>
+          <p:cNvPr id="8" name="TextBox 7"/>
+          <p:cNvSpPr txBox="1"/>
+          <p:nvPr/>
+        </p:nvSpPr>
+        <p:spPr>
+          <a:xfrm>
+            <a:off x="914400" y="2148840"/>
+            <a:ext cx="10698480" cy="502920"/>
+          </a:xfrm>
+          <a:prstGeom prst="rect">
+            <a:avLst/>
+          </a:prstGeom>
+          <a:noFill/>
+        </p:spPr>
+        <p:txBody>
+          <a:bodyPr wrap="square" anchor="t" lIns="0" rIns="0" tIns="0" bIns="0">
+            <a:spAutoFit/>
+          </a:bodyPr>
+          <a:lstStyle/>
+          <a:p>
+            <a:pPr algn="l">
+              <a:lnSpc>
+                <a:spcPct val="115000"/>
+              </a:lnSpc>
+            </a:pPr>
+            <a:r>
+              <a:rPr sz="1100" b="0" i="0">
+                <a:solidFill>
+                  <a:srgbClr val="410F37"/>
+                </a:solidFill>
+                <a:latin typeface="Inter"/>
+              </a:rPr>
+              <a:t>FCDO and Swiss reimburse in arrears; cash-flow discipline remains critical. Detail in papers 04 (Reserves Prognosis) and 05 (Y2D Grant Spend).</a:t>
+            </a:r>
+          </a:p>
+        </p:txBody>
+      </p:sp>
+      <p:sp>
+        <p:nvSpPr>
+          <p:cNvPr id="9" name="Rectangle 8"/>
+          <p:cNvSpPr/>
+          <p:nvPr/>
+        </p:nvSpPr>
+        <p:spPr>
+          <a:xfrm>
+            <a:off x="640080" y="2697480"/>
+            <a:ext cx="137160" cy="777240"/>
+          </a:xfrm>
+          <a:prstGeom prst="rect">
+            <a:avLst/>
+          </a:prstGeom>
+          <a:solidFill>
+            <a:srgbClr val="E12D64"/>
+          </a:solidFill>
+          <a:ln>
+            <a:noFill/>
+          </a:ln>
+          <a:effectLst/>
+        </p:spPr>
+        <p:style>
+          <a:lnRef idx="1">
+            <a:schemeClr val="accent1"/>
+          </a:lnRef>
+          <a:fillRef idx="3">
+            <a:schemeClr val="accent1"/>
+          </a:fillRef>
+          <a:effectRef idx="2">
+            <a:schemeClr val="accent1"/>
+          </a:effectRef>
+          <a:fontRef idx="minor">
+            <a:schemeClr val="lt1"/>
+          </a:fontRef>
+        </p:style>
+        <p:txBody>
+          <a:bodyPr rtlCol="0" anchor="ctr"/>
+          <a:lstStyle/>
+          <a:p>
+            <a:pPr algn="ctr"/>
+          </a:p>
+        </p:txBody>
+      </p:sp>
+      <p:sp>
+        <p:nvSpPr>
+          <p:cNvPr id="10" name="TextBox 9"/>
+          <p:cNvSpPr txBox="1"/>
+          <p:nvPr/>
+        </p:nvSpPr>
+        <p:spPr>
+          <a:xfrm>
+            <a:off x="914400" y="2697480"/>
+            <a:ext cx="10698480" cy="365760"/>
+          </a:xfrm>
+          <a:prstGeom prst="rect">
+            <a:avLst/>
+          </a:prstGeom>
+          <a:noFill/>
+        </p:spPr>
+        <p:txBody>
+          <a:bodyPr wrap="square" anchor="t" lIns="0" rIns="0" tIns="0" bIns="0">
+            <a:spAutoFit/>
+          </a:bodyPr>
+          <a:lstStyle/>
+          <a:p>
+            <a:pPr algn="l">
+              <a:lnSpc>
+                <a:spcPct val="115000"/>
+              </a:lnSpc>
+            </a:pPr>
+            <a:r>
+              <a:rPr sz="1300" b="1" i="0">
+                <a:solidFill>
+                  <a:srgbClr val="410F37"/>
+                </a:solidFill>
+                <a:latin typeface="Inter"/>
+              </a:rPr>
+              <a:t>VAI ↔ hūmānus entity transition</a:t>
+            </a:r>
+          </a:p>
+        </p:txBody>
+      </p:sp>
+      <p:sp>
+        <p:nvSpPr>
+          <p:cNvPr id="11" name="TextBox 10"/>
+          <p:cNvSpPr txBox="1"/>
+          <p:nvPr/>
+        </p:nvSpPr>
+        <p:spPr>
+          <a:xfrm>
+            <a:off x="914400" y="3017520"/>
+            <a:ext cx="10698480" cy="502920"/>
+          </a:xfrm>
+          <a:prstGeom prst="rect">
+            <a:avLst/>
+          </a:prstGeom>
+          <a:noFill/>
+        </p:spPr>
+        <p:txBody>
+          <a:bodyPr wrap="square" anchor="t" lIns="0" rIns="0" tIns="0" bIns="0">
+            <a:spAutoFit/>
+          </a:bodyPr>
+          <a:lstStyle/>
+          <a:p>
+            <a:pPr algn="l">
+              <a:lnSpc>
+                <a:spcPct val="115000"/>
+              </a:lnSpc>
+            </a:pPr>
+            <a:r>
+              <a:rPr sz="1100" b="0" i="0">
+                <a:solidFill>
+                  <a:srgbClr val="410F37"/>
+                </a:solidFill>
+                <a:latin typeface="Inter"/>
+              </a:rPr>
+              <a:t>Two active Swiss-funded workstreams straddle the transition — SDC Women's Dialogue closing out under VAI; Swiss/Stimson Arakan running under hūmānus.</a:t>
+            </a:r>
+          </a:p>
+        </p:txBody>
+      </p:sp>
+      <p:sp>
+        <p:nvSpPr>
+          <p:cNvPr id="12" name="Rectangle 11"/>
+          <p:cNvSpPr/>
+          <p:nvPr/>
+        </p:nvSpPr>
+        <p:spPr>
+          <a:xfrm>
+            <a:off x="640080" y="3566160"/>
+            <a:ext cx="137160" cy="777240"/>
+          </a:xfrm>
+          <a:prstGeom prst="rect">
+            <a:avLst/>
+          </a:prstGeom>
+          <a:solidFill>
+            <a:srgbClr val="E12D64"/>
+          </a:solidFill>
+          <a:ln>
+            <a:noFill/>
+          </a:ln>
+          <a:effectLst/>
+        </p:spPr>
+        <p:style>
+          <a:lnRef idx="1">
+            <a:schemeClr val="accent1"/>
+          </a:lnRef>
+          <a:fillRef idx="3">
+            <a:schemeClr val="accent1"/>
+          </a:fillRef>
+          <a:effectRef idx="2">
+            <a:schemeClr val="accent1"/>
+          </a:effectRef>
+          <a:fontRef idx="minor">
+            <a:schemeClr val="lt1"/>
+          </a:fontRef>
+        </p:style>
+        <p:txBody>
+          <a:bodyPr rtlCol="0" anchor="ctr"/>
+          <a:lstStyle/>
+          <a:p>
+            <a:pPr algn="ctr"/>
+          </a:p>
+        </p:txBody>
+      </p:sp>
+      <p:sp>
+        <p:nvSpPr>
+          <p:cNvPr id="13" name="TextBox 12"/>
+          <p:cNvSpPr txBox="1"/>
+          <p:nvPr/>
+        </p:nvSpPr>
+        <p:spPr>
+          <a:xfrm>
+            <a:off x="914400" y="3566160"/>
+            <a:ext cx="10698480" cy="365760"/>
+          </a:xfrm>
+          <a:prstGeom prst="rect">
+            <a:avLst/>
+          </a:prstGeom>
+          <a:noFill/>
+        </p:spPr>
+        <p:txBody>
+          <a:bodyPr wrap="square" anchor="t" lIns="0" rIns="0" tIns="0" bIns="0">
+            <a:spAutoFit/>
+          </a:bodyPr>
+          <a:lstStyle/>
+          <a:p>
+            <a:pPr algn="l">
+              <a:lnSpc>
+                <a:spcPct val="115000"/>
+              </a:lnSpc>
+            </a:pPr>
+            <a:r>
+              <a:rPr sz="1300" b="1" i="0">
+                <a:solidFill>
+                  <a:srgbClr val="410F37"/>
+                </a:solidFill>
+                <a:latin typeface="Inter"/>
+              </a:rPr>
+              <a:t>Bangladesh operating environment</a:t>
+            </a:r>
+          </a:p>
+        </p:txBody>
+      </p:sp>
+      <p:sp>
+        <p:nvSpPr>
+          <p:cNvPr id="14" name="TextBox 13"/>
+          <p:cNvSpPr txBox="1"/>
+          <p:nvPr/>
+        </p:nvSpPr>
+        <p:spPr>
+          <a:xfrm>
+            <a:off x="914400" y="3886200"/>
+            <a:ext cx="10698480" cy="502920"/>
+          </a:xfrm>
+          <a:prstGeom prst="rect">
+            <a:avLst/>
+          </a:prstGeom>
+          <a:noFill/>
+        </p:spPr>
+        <p:txBody>
+          <a:bodyPr wrap="square" anchor="t" lIns="0" rIns="0" tIns="0" bIns="0">
+            <a:spAutoFit/>
+          </a:bodyPr>
+          <a:lstStyle/>
+          <a:p>
+            <a:pPr algn="l">
+              <a:lnSpc>
+                <a:spcPct val="115000"/>
+              </a:lnSpc>
+            </a:pPr>
+            <a:r>
+              <a:rPr sz="1100" b="0" i="0">
+                <a:solidFill>
+                  <a:srgbClr val="410F37"/>
+                </a:solidFill>
+                <a:latin typeface="Inter"/>
+              </a:rPr>
+              <a:t>Political situation under the new government continues to shape Bangladesh dialogue and Stimson partnership delivery.</a:t>
+            </a:r>
+          </a:p>
+        </p:txBody>
+      </p:sp>
+      <p:sp>
+        <p:nvSpPr>
+          <p:cNvPr id="15" name="Rectangle 14"/>
+          <p:cNvSpPr/>
+          <p:nvPr/>
+        </p:nvSpPr>
+        <p:spPr>
+          <a:xfrm>
+            <a:off x="640080" y="4434840"/>
+            <a:ext cx="137160" cy="777240"/>
+          </a:xfrm>
+          <a:prstGeom prst="rect">
+            <a:avLst/>
+          </a:prstGeom>
+          <a:solidFill>
+            <a:srgbClr val="E12D64"/>
+          </a:solidFill>
+          <a:ln>
+            <a:noFill/>
+          </a:ln>
+          <a:effectLst/>
+        </p:spPr>
+        <p:style>
+          <a:lnRef idx="1">
+            <a:schemeClr val="accent1"/>
+          </a:lnRef>
+          <a:fillRef idx="3">
+            <a:schemeClr val="accent1"/>
+          </a:fillRef>
+          <a:effectRef idx="2">
+            <a:schemeClr val="accent1"/>
+          </a:effectRef>
+          <a:fontRef idx="minor">
+            <a:schemeClr val="lt1"/>
+          </a:fontRef>
+        </p:style>
+        <p:txBody>
+          <a:bodyPr rtlCol="0" anchor="ctr"/>
+          <a:lstStyle/>
+          <a:p>
+            <a:pPr algn="ctr"/>
+          </a:p>
+        </p:txBody>
+      </p:sp>
+      <p:sp>
+        <p:nvSpPr>
+          <p:cNvPr id="16" name="TextBox 15"/>
+          <p:cNvSpPr txBox="1"/>
+          <p:nvPr/>
+        </p:nvSpPr>
+        <p:spPr>
+          <a:xfrm>
+            <a:off x="914400" y="4434840"/>
+            <a:ext cx="10698480" cy="365760"/>
+          </a:xfrm>
+          <a:prstGeom prst="rect">
+            <a:avLst/>
+          </a:prstGeom>
+          <a:noFill/>
+        </p:spPr>
+        <p:txBody>
+          <a:bodyPr wrap="square" anchor="t" lIns="0" rIns="0" tIns="0" bIns="0">
+            <a:spAutoFit/>
+          </a:bodyPr>
+          <a:lstStyle/>
+          <a:p>
+            <a:pPr algn="l">
+              <a:lnSpc>
+                <a:spcPct val="115000"/>
+              </a:lnSpc>
+            </a:pPr>
+            <a:r>
+              <a:rPr sz="1300" b="1" i="0">
+                <a:solidFill>
+                  <a:srgbClr val="410F37"/>
+                </a:solidFill>
+                <a:latin typeface="Inter"/>
+              </a:rPr>
+              <a:t>Beyond 2029 / post-OSF horizon</a:t>
+            </a:r>
+          </a:p>
+        </p:txBody>
+      </p:sp>
+      <p:sp>
+        <p:nvSpPr>
+          <p:cNvPr id="17" name="TextBox 16"/>
+          <p:cNvSpPr txBox="1"/>
+          <p:nvPr/>
+        </p:nvSpPr>
+        <p:spPr>
+          <a:xfrm>
+            <a:off x="914400" y="4754880"/>
+            <a:ext cx="10698480" cy="502920"/>
+          </a:xfrm>
+          <a:prstGeom prst="rect">
+            <a:avLst/>
+          </a:prstGeom>
+          <a:noFill/>
+        </p:spPr>
+        <p:txBody>
+          <a:bodyPr wrap="square" anchor="t" lIns="0" rIns="0" tIns="0" bIns="0">
+            <a:spAutoFit/>
+          </a:bodyPr>
+          <a:lstStyle/>
+          <a:p>
+            <a:pPr algn="l">
+              <a:lnSpc>
+                <a:spcPct val="115000"/>
+              </a:lnSpc>
+            </a:pPr>
+            <a:r>
+              <a:rPr sz="1100" b="0" i="0">
+                <a:solidFill>
+                  <a:srgbClr val="410F37"/>
+                </a:solidFill>
+                <a:latin typeface="Inter"/>
+              </a:rPr>
+              <a:t>Picked up under agenda item 6 (strategic discussion) — matching ambition to a minimal-fundraising posture.</a:t>
+            </a:r>
+          </a:p>
+        </p:txBody>
+      </p:sp>
+      <p:sp>
+        <p:nvSpPr>
+          <p:cNvPr id="18" name="Rectangle 17"/>
+          <p:cNvSpPr/>
+          <p:nvPr/>
+        </p:nvSpPr>
+        <p:spPr>
+          <a:xfrm>
+            <a:off x="640080" y="5303520"/>
+            <a:ext cx="137160" cy="777240"/>
+          </a:xfrm>
+          <a:prstGeom prst="rect">
+            <a:avLst/>
+          </a:prstGeom>
+          <a:solidFill>
+            <a:srgbClr val="E12D64"/>
+          </a:solidFill>
+          <a:ln>
+            <a:noFill/>
+          </a:ln>
+          <a:effectLst/>
+        </p:spPr>
+        <p:style>
+          <a:lnRef idx="1">
+            <a:schemeClr val="accent1"/>
+          </a:lnRef>
+          <a:fillRef idx="3">
+            <a:schemeClr val="accent1"/>
+          </a:fillRef>
+          <a:effectRef idx="2">
+            <a:schemeClr val="accent1"/>
+          </a:effectRef>
+          <a:fontRef idx="minor">
+            <a:schemeClr val="lt1"/>
+          </a:fontRef>
+        </p:style>
+        <p:txBody>
+          <a:bodyPr rtlCol="0" anchor="ctr"/>
+          <a:lstStyle/>
+          <a:p>
+            <a:pPr algn="ctr"/>
+          </a:p>
+        </p:txBody>
+      </p:sp>
+      <p:sp>
+        <p:nvSpPr>
+          <p:cNvPr id="19" name="TextBox 18"/>
+          <p:cNvSpPr txBox="1"/>
+          <p:nvPr/>
+        </p:nvSpPr>
+        <p:spPr>
+          <a:xfrm>
+            <a:off x="914400" y="5303520"/>
+            <a:ext cx="10698480" cy="365760"/>
+          </a:xfrm>
+          <a:prstGeom prst="rect">
+            <a:avLst/>
+          </a:prstGeom>
+          <a:noFill/>
+        </p:spPr>
+        <p:txBody>
+          <a:bodyPr wrap="square" anchor="t" lIns="0" rIns="0" tIns="0" bIns="0">
+            <a:spAutoFit/>
+          </a:bodyPr>
+          <a:lstStyle/>
+          <a:p>
+            <a:pPr algn="l">
+              <a:lnSpc>
+                <a:spcPct val="115000"/>
+              </a:lnSpc>
+            </a:pPr>
+            <a:r>
+              <a:rPr sz="1300" b="1" i="0">
+                <a:solidFill>
+                  <a:srgbClr val="410F37"/>
+                </a:solidFill>
+                <a:latin typeface="Inter"/>
+              </a:rPr>
+              <a:t>Hiring posture</a:t>
+            </a:r>
+          </a:p>
+        </p:txBody>
+      </p:sp>
+      <p:sp>
+        <p:nvSpPr>
+          <p:cNvPr id="20" name="TextBox 19"/>
+          <p:cNvSpPr txBox="1"/>
+          <p:nvPr/>
+        </p:nvSpPr>
+        <p:spPr>
+          <a:xfrm>
+            <a:off x="914400" y="5623560"/>
+            <a:ext cx="10698480" cy="502920"/>
+          </a:xfrm>
+          <a:prstGeom prst="rect">
+            <a:avLst/>
+          </a:prstGeom>
+          <a:noFill/>
+        </p:spPr>
+        <p:txBody>
+          <a:bodyPr wrap="square" anchor="t" lIns="0" rIns="0" tIns="0" bIns="0">
+            <a:spAutoFit/>
+          </a:bodyPr>
+          <a:lstStyle/>
+          <a:p>
+            <a:pPr algn="l">
+              <a:lnSpc>
+                <a:spcPct val="115000"/>
+              </a:lnSpc>
+            </a:pPr>
+            <a:r>
+              <a:rPr sz="1100" b="0" i="0">
+                <a:solidFill>
+                  <a:srgbClr val="410F37"/>
+                </a:solidFill>
+                <a:latin typeface="Inter"/>
+              </a:rPr>
+              <a:t>Eva remains cautious on new permanent hires in the short term following Q1 reflection; no new joiners Feb–May 2026.</a:t>
+            </a:r>
+          </a:p>
+        </p:txBody>
+      </p:sp>
+      <p:sp>
+        <p:nvSpPr>
+          <p:cNvPr id="21" name="TextBox 20"/>
+          <p:cNvSpPr txBox="1"/>
+          <p:nvPr/>
+        </p:nvSpPr>
+        <p:spPr>
+          <a:xfrm>
+            <a:off x="640080" y="6492240"/>
+            <a:ext cx="7315200" cy="274320"/>
+          </a:xfrm>
+          <a:prstGeom prst="rect">
+            <a:avLst/>
+          </a:prstGeom>
+          <a:noFill/>
+        </p:spPr>
+        <p:txBody>
+          <a:bodyPr wrap="square" anchor="t" lIns="0" rIns="0" tIns="0" bIns="0">
+            <a:spAutoFit/>
+          </a:bodyPr>
+          <a:lstStyle/>
+          <a:p>
+            <a:pPr algn="l">
+              <a:lnSpc>
+                <a:spcPct val="115000"/>
+              </a:lnSpc>
+            </a:pPr>
+            <a:r>
+              <a:rPr sz="900" b="0" i="0">
+                <a:solidFill>
+                  <a:srgbClr val="410F37"/>
+                </a:solidFill>
+                <a:latin typeface="Inter"/>
+              </a:rPr>
+              <a:t>hūmānus  ·  Q2 2026 Board Meeting  ·  Operations &amp; Impact Update</a:t>
+            </a:r>
+          </a:p>
+        </p:txBody>
+      </p:sp>
+      <p:sp>
+        <p:nvSpPr>
+          <p:cNvPr id="22" name="TextBox 21"/>
+          <p:cNvSpPr txBox="1"/>
+          <p:nvPr/>
+        </p:nvSpPr>
+        <p:spPr>
+          <a:xfrm>
+            <a:off x="10332720" y="6492240"/>
+            <a:ext cx="1371600" cy="274320"/>
+          </a:xfrm>
+          <a:prstGeom prst="rect">
+            <a:avLst/>
+          </a:prstGeom>
+          <a:noFill/>
+        </p:spPr>
+        <p:txBody>
+          <a:bodyPr wrap="square" anchor="t" lIns="0" rIns="0" tIns="0" bIns="0">
+            <a:spAutoFit/>
+          </a:bodyPr>
+          <a:lstStyle/>
+          <a:p>
+            <a:pPr algn="r">
+              <a:lnSpc>
+                <a:spcPct val="115000"/>
+              </a:lnSpc>
+            </a:pPr>
+            <a:r>
+              <a:rPr sz="900" b="0" i="0">
+                <a:solidFill>
+                  <a:srgbClr val="410F37"/>
+                </a:solidFill>
+                <a:latin typeface="Inter"/>
+              </a:rPr>
+              <a:t>10 / 11</a:t>
+            </a:r>
+          </a:p>
+        </p:txBody>
+      </p:sp>
+    </p:spTree>
+  </p:cSld>
+  <p:clrMapOvr>
+    <a:masterClrMapping/>
+  </p:clrMapOvr>
+</p:sld>
+</file>
+
+<file path=ppt/slides/slide11.xml><?xml version="1.0" encoding="utf-8"?>
+<p:sld xmlns:a="http://schemas.openxmlformats.org/drawingml/2006/main" xmlns:p="http://schemas.openxmlformats.org/presentationml/2006/main" xmlns:r="http://schemas.openxmlformats.org/officeDocument/2006/relationships">
+  <p:cSld>
+    <p:spTree>
+      <p:nvGrpSpPr>
+        <p:cNvPr id="1" name=""/>
+        <p:cNvGrpSpPr/>
+        <p:nvPr/>
+      </p:nvGrpSpPr>
+      <p:grpSpPr/>
+      <p:sp>
+        <p:nvSpPr>
+          <p:cNvPr id="2" name="Rectangle 1"/>
+          <p:cNvSpPr/>
+          <p:nvPr/>
+        </p:nvSpPr>
+        <p:spPr>
+          <a:xfrm>
+            <a:off x="0" y="0"/>
+            <a:ext cx="12191695" cy="6858000"/>
+          </a:xfrm>
+          <a:prstGeom prst="rect">
+            <a:avLst/>
+          </a:prstGeom>
+          <a:solidFill>
             <a:srgbClr val="410F37"/>
           </a:solidFill>
           <a:ln>
@@ -4335,7 +5207,7 @@
                 </a:solidFill>
                 <a:latin typeface="Inter"/>
               </a:rPr>
-              <a:t>2 / 10</a:t>
+              <a:t>2 / 11</a:t>
             </a:r>
           </a:p>
         </p:txBody>
@@ -5762,7 +6634,7 @@
                 </a:solidFill>
                 <a:latin typeface="Inter"/>
               </a:rPr>
-              <a:t>3 / 10</a:t>
+              <a:t>3 / 11</a:t>
             </a:r>
           </a:p>
         </p:txBody>
@@ -6389,7 +7261,7 @@
                 </a:solidFill>
                 <a:latin typeface="Inter"/>
               </a:rPr>
-              <a:t>4 / 10</a:t>
+              <a:t>4 / 11</a:t>
             </a:r>
           </a:p>
         </p:txBody>
@@ -7016,7 +7888,7 @@
                 </a:solidFill>
                 <a:latin typeface="Inter"/>
               </a:rPr>
-              <a:t>5 / 10</a:t>
+              <a:t>5 / 11</a:t>
             </a:r>
           </a:p>
         </p:txBody>
@@ -7726,7 +8598,7 @@
                 </a:solidFill>
                 <a:latin typeface="Inter"/>
               </a:rPr>
-              <a:t>6 / 10</a:t>
+              <a:t>6 / 11</a:t>
             </a:r>
           </a:p>
         </p:txBody>
@@ -8353,7 +9225,7 @@
                 </a:solidFill>
                 <a:latin typeface="Inter"/>
               </a:rPr>
-              <a:t>7 / 10</a:t>
+              <a:t>7 / 11</a:t>
             </a:r>
           </a:p>
         </p:txBody>
@@ -8391,7 +9263,7 @@
             <a:avLst/>
           </a:prstGeom>
           <a:solidFill>
-            <a:srgbClr val="FFFFFF"/>
+            <a:srgbClr val="410F37"/>
           </a:solidFill>
           <a:ln>
             <a:noFill/>
@@ -8419,45 +9291,30 @@
           </a:p>
         </p:txBody>
       </p:sp>
-      <p:sp>
-        <p:nvSpPr>
-          <p:cNvPr id="3" name="TextBox 2"/>
-          <p:cNvSpPr txBox="1"/>
-          <p:nvPr/>
-        </p:nvSpPr>
-        <p:spPr>
-          <a:xfrm>
-            <a:off x="640080" y="502920"/>
-            <a:ext cx="10972800" cy="548640"/>
-          </a:xfrm>
-          <a:prstGeom prst="rect">
-            <a:avLst/>
-          </a:prstGeom>
-          <a:noFill/>
-        </p:spPr>
-        <p:txBody>
-          <a:bodyPr wrap="square" anchor="t" lIns="0" rIns="0" tIns="0" bIns="0">
-            <a:spAutoFit/>
-          </a:bodyPr>
-          <a:lstStyle/>
-          <a:p>
-            <a:pPr algn="l">
-              <a:lnSpc>
-                <a:spcPct val="115000"/>
-              </a:lnSpc>
-            </a:pPr>
-            <a:r>
-              <a:rPr sz="2800" b="1" i="0">
-                <a:solidFill>
-                  <a:srgbClr val="410F37"/>
-                </a:solidFill>
-                <a:latin typeface="Inter"/>
-              </a:rPr>
-              <a:t>Other significant work</a:t>
-            </a:r>
-          </a:p>
-        </p:txBody>
-      </p:sp>
+      <p:pic>
+        <p:nvPicPr>
+          <p:cNvPr id="3" name="Picture 2" descr="EVA_Frontline_020426-07770.JPG"/>
+          <p:cNvPicPr>
+            <a:picLocks noChangeAspect="1"/>
+          </p:cNvPicPr>
+          <p:nvPr/>
+        </p:nvPicPr>
+        <p:blipFill>
+          <a:blip r:embed="rId2"/>
+          <a:stretch>
+            <a:fillRect/>
+          </a:stretch>
+        </p:blipFill>
+        <p:spPr>
+          <a:xfrm>
+            <a:off x="4114800" y="0"/>
+            <a:ext cx="8076895" cy="6858000"/>
+          </a:xfrm>
+          <a:prstGeom prst="rect">
+            <a:avLst/>
+          </a:prstGeom>
+        </p:spPr>
+      </p:pic>
       <p:sp>
         <p:nvSpPr>
           <p:cNvPr id="4" name="Rectangle 3"/>
@@ -8466,7 +9323,145 @@
         </p:nvSpPr>
         <p:spPr>
           <a:xfrm>
-            <a:off x="640080" y="1097280"/>
+            <a:off x="0" y="0"/>
+            <a:ext cx="4114800" cy="6858000"/>
+          </a:xfrm>
+          <a:prstGeom prst="rect">
+            <a:avLst/>
+          </a:prstGeom>
+          <a:solidFill>
+            <a:srgbClr val="410F37"/>
+          </a:solidFill>
+          <a:ln>
+            <a:noFill/>
+          </a:ln>
+          <a:effectLst/>
+        </p:spPr>
+        <p:style>
+          <a:lnRef idx="1">
+            <a:schemeClr val="accent1"/>
+          </a:lnRef>
+          <a:fillRef idx="3">
+            <a:schemeClr val="accent1"/>
+          </a:fillRef>
+          <a:effectRef idx="2">
+            <a:schemeClr val="accent1"/>
+          </a:effectRef>
+          <a:fontRef idx="minor">
+            <a:schemeClr val="lt1"/>
+          </a:fontRef>
+        </p:style>
+        <p:txBody>
+          <a:bodyPr rtlCol="0" anchor="ctr"/>
+          <a:lstStyle/>
+          <a:p>
+            <a:pPr algn="ctr"/>
+          </a:p>
+        </p:txBody>
+      </p:sp>
+      <p:sp>
+        <p:nvSpPr>
+          <p:cNvPr id="5" name="TextBox 4"/>
+          <p:cNvSpPr txBox="1"/>
+          <p:nvPr/>
+        </p:nvSpPr>
+        <p:spPr>
+          <a:xfrm>
+            <a:off x="548640" y="640080"/>
+            <a:ext cx="3383280" cy="365760"/>
+          </a:xfrm>
+          <a:prstGeom prst="rect">
+            <a:avLst/>
+          </a:prstGeom>
+          <a:noFill/>
+        </p:spPr>
+        <p:txBody>
+          <a:bodyPr wrap="square" anchor="t" lIns="0" rIns="0" tIns="0" bIns="0">
+            <a:spAutoFit/>
+          </a:bodyPr>
+          <a:lstStyle/>
+          <a:p>
+            <a:pPr algn="l">
+              <a:lnSpc>
+                <a:spcPct val="115000"/>
+              </a:lnSpc>
+            </a:pPr>
+            <a:r>
+              <a:rPr sz="1100" b="1" i="0">
+                <a:solidFill>
+                  <a:srgbClr val="96FF14"/>
+                </a:solidFill>
+                <a:latin typeface="Inter"/>
+              </a:rPr>
+              <a:t>PUBLIC ENGAGEMENT</a:t>
+            </a:r>
+          </a:p>
+        </p:txBody>
+      </p:sp>
+      <p:sp>
+        <p:nvSpPr>
+          <p:cNvPr id="6" name="TextBox 5"/>
+          <p:cNvSpPr txBox="1"/>
+          <p:nvPr/>
+        </p:nvSpPr>
+        <p:spPr>
+          <a:xfrm>
+            <a:off x="548640" y="1051560"/>
+            <a:ext cx="3383280" cy="1645920"/>
+          </a:xfrm>
+          <a:prstGeom prst="rect">
+            <a:avLst/>
+          </a:prstGeom>
+          <a:noFill/>
+        </p:spPr>
+        <p:txBody>
+          <a:bodyPr wrap="square" anchor="t" lIns="0" rIns="0" tIns="0" bIns="0">
+            <a:spAutoFit/>
+          </a:bodyPr>
+          <a:lstStyle/>
+          <a:p>
+            <a:pPr algn="l">
+              <a:lnSpc>
+                <a:spcPct val="105000"/>
+              </a:lnSpc>
+            </a:pPr>
+            <a:r>
+              <a:rPr sz="3200" b="1" i="0">
+                <a:solidFill>
+                  <a:srgbClr val="FFFFFF"/>
+                </a:solidFill>
+                <a:latin typeface="Inter"/>
+              </a:rPr>
+              <a:t>Frontline Club</a:t>
+            </a:r>
+          </a:p>
+          <a:p>
+            <a:pPr algn="l">
+              <a:lnSpc>
+                <a:spcPct val="105000"/>
+              </a:lnSpc>
+            </a:pPr>
+            <a:r>
+              <a:rPr sz="3200" b="1" i="0">
+                <a:solidFill>
+                  <a:srgbClr val="FFFFFF"/>
+                </a:solidFill>
+                <a:latin typeface="Inter"/>
+              </a:rPr>
+              <a:t>panel — London</a:t>
+            </a:r>
+          </a:p>
+        </p:txBody>
+      </p:sp>
+      <p:sp>
+        <p:nvSpPr>
+          <p:cNvPr id="7" name="Rectangle 6"/>
+          <p:cNvSpPr/>
+          <p:nvPr/>
+        </p:nvSpPr>
+        <p:spPr>
+          <a:xfrm>
+            <a:off x="548640" y="2788920"/>
             <a:ext cx="548640" cy="54864"/>
           </a:xfrm>
           <a:prstGeom prst="rect">
@@ -8504,14 +9499,14 @@
       </p:sp>
       <p:sp>
         <p:nvSpPr>
-          <p:cNvPr id="5" name="TextBox 4"/>
-          <p:cNvSpPr txBox="1"/>
-          <p:nvPr/>
-        </p:nvSpPr>
-        <p:spPr>
-          <a:xfrm>
-            <a:off x="640080" y="1280160"/>
-            <a:ext cx="10972800" cy="457200"/>
+          <p:cNvPr id="8" name="TextBox 7"/>
+          <p:cNvSpPr txBox="1"/>
+          <p:nvPr/>
+        </p:nvSpPr>
+        <p:spPr>
+          <a:xfrm>
+            <a:off x="548640" y="2971800"/>
+            <a:ext cx="3383280" cy="365760"/>
           </a:xfrm>
           <a:prstGeom prst="rect">
             <a:avLst/>
@@ -8530,27 +9525,27 @@
               </a:lnSpc>
             </a:pPr>
             <a:r>
-              <a:rPr sz="1300" b="0" i="1">
-                <a:solidFill>
-                  <a:srgbClr val="E12D64"/>
-                </a:solidFill>
-                <a:latin typeface="Inter"/>
-              </a:rPr>
-              <a:t>Not externally project-funded, or peripheral to the funded portfolio.</a:t>
-            </a:r>
-          </a:p>
-        </p:txBody>
-      </p:sp>
-      <p:sp>
-        <p:nvSpPr>
-          <p:cNvPr id="6" name="TextBox 5"/>
-          <p:cNvSpPr txBox="1"/>
-          <p:nvPr/>
-        </p:nvSpPr>
-        <p:spPr>
-          <a:xfrm>
-            <a:off x="640080" y="1828800"/>
-            <a:ext cx="5394960" cy="457200"/>
+              <a:rPr sz="1400" b="0" i="1">
+                <a:solidFill>
+                  <a:srgbClr val="96FF14"/>
+                </a:solidFill>
+                <a:latin typeface="Inter"/>
+              </a:rPr>
+              <a:t>Human Rights in a Fragmenting World</a:t>
+            </a:r>
+          </a:p>
+        </p:txBody>
+      </p:sp>
+      <p:sp>
+        <p:nvSpPr>
+          <p:cNvPr id="9" name="TextBox 8"/>
+          <p:cNvSpPr txBox="1"/>
+          <p:nvPr/>
+        </p:nvSpPr>
+        <p:spPr>
+          <a:xfrm>
+            <a:off x="548640" y="3383280"/>
+            <a:ext cx="3383280" cy="365760"/>
           </a:xfrm>
           <a:prstGeom prst="rect">
             <a:avLst/>
@@ -8569,27 +9564,27 @@
               </a:lnSpc>
             </a:pPr>
             <a:r>
-              <a:rPr sz="1400" b="1" i="0">
-                <a:solidFill>
-                  <a:srgbClr val="410F37"/>
-                </a:solidFill>
-                <a:latin typeface="Inter"/>
-              </a:rPr>
-              <a:t>Adani / UniSuper / APRA strand</a:t>
-            </a:r>
-          </a:p>
-        </p:txBody>
-      </p:sp>
-      <p:sp>
-        <p:nvSpPr>
-          <p:cNvPr id="7" name="TextBox 6"/>
-          <p:cNvSpPr txBox="1"/>
-          <p:nvPr/>
-        </p:nvSpPr>
-        <p:spPr>
-          <a:xfrm>
-            <a:off x="640080" y="2240280"/>
-            <a:ext cx="5394960" cy="1828800"/>
+              <a:rPr sz="1200" b="0" i="0">
+                <a:solidFill>
+                  <a:srgbClr val="FFFFFF"/>
+                </a:solidFill>
+                <a:latin typeface="Inter"/>
+              </a:rPr>
+              <a:t>2 April 2026</a:t>
+            </a:r>
+          </a:p>
+        </p:txBody>
+      </p:sp>
+      <p:sp>
+        <p:nvSpPr>
+          <p:cNvPr id="10" name="TextBox 9"/>
+          <p:cNvSpPr txBox="1"/>
+          <p:nvPr/>
+        </p:nvSpPr>
+        <p:spPr>
+          <a:xfrm>
+            <a:off x="548640" y="4114800"/>
+            <a:ext cx="3383280" cy="2103120"/>
           </a:xfrm>
           <a:prstGeom prst="rect">
             <a:avLst/>
@@ -8604,31 +9599,31 @@
           <a:p>
             <a:pPr algn="l">
               <a:lnSpc>
-                <a:spcPct val="115000"/>
+                <a:spcPct val="130000"/>
               </a:lnSpc>
             </a:pPr>
             <a:r>
               <a:rPr sz="1100" b="0" i="0">
                 <a:solidFill>
-                  <a:srgbClr val="410F37"/>
-                </a:solidFill>
-                <a:latin typeface="Inter"/>
-              </a:rPr>
-              <a:t>New and active workstream from March 2026. Includes APRA complaint work (Cbus deep-dive), Adani Investors briefings (Australian fiduciary case law, super-fund exposure to Adani / GQG), Adani Defence scoping, OFAC Iran civil-probe briefing, and a UniSuper PHD review. Substantial volume — Board may wish to take a dedicated update at a future meeting.</a:t>
-            </a:r>
-          </a:p>
-        </p:txBody>
-      </p:sp>
-      <p:sp>
-        <p:nvSpPr>
-          <p:cNvPr id="8" name="TextBox 7"/>
-          <p:cNvSpPr txBox="1"/>
-          <p:nvPr/>
-        </p:nvSpPr>
-        <p:spPr>
-          <a:xfrm>
-            <a:off x="640080" y="4572000"/>
-            <a:ext cx="5394960" cy="457200"/>
+                  <a:srgbClr val="FFFFFF"/>
+                </a:solidFill>
+                <a:latin typeface="Inter"/>
+              </a:rPr>
+              <a:t>A hūmānus-branded panel at the Frontline Club, bringing together our Rohingya-in-India work, dialogue work, and wider accountability practice in front of a London press and policy audience. Featured-speaker videos (Aditi and Nazia) approved end-May for onward circulation.</a:t>
+            </a:r>
+          </a:p>
+        </p:txBody>
+      </p:sp>
+      <p:sp>
+        <p:nvSpPr>
+          <p:cNvPr id="11" name="TextBox 10"/>
+          <p:cNvSpPr txBox="1"/>
+          <p:nvPr/>
+        </p:nvSpPr>
+        <p:spPr>
+          <a:xfrm>
+            <a:off x="548640" y="6492240"/>
+            <a:ext cx="3383280" cy="274320"/>
           </a:xfrm>
           <a:prstGeom prst="rect">
             <a:avLst/>
@@ -8647,130 +9642,13 @@
               </a:lnSpc>
             </a:pPr>
             <a:r>
-              <a:rPr sz="1400" b="1" i="0">
-                <a:solidFill>
-                  <a:srgbClr val="410F37"/>
-                </a:solidFill>
-                <a:latin typeface="Inter"/>
-              </a:rPr>
-              <a:t>Meta Inc. accountability &amp; Mohib Ullah</a:t>
-            </a:r>
-          </a:p>
-        </p:txBody>
-      </p:sp>
-      <p:sp>
-        <p:nvSpPr>
-          <p:cNvPr id="9" name="TextBox 8"/>
-          <p:cNvSpPr txBox="1"/>
-          <p:nvPr/>
-        </p:nvSpPr>
-        <p:spPr>
-          <a:xfrm>
-            <a:off x="640080" y="4983480"/>
-            <a:ext cx="5394960" cy="1371600"/>
-          </a:xfrm>
-          <a:prstGeom prst="rect">
-            <a:avLst/>
-          </a:prstGeom>
-          <a:noFill/>
-        </p:spPr>
-        <p:txBody>
-          <a:bodyPr wrap="square" anchor="t" lIns="0" rIns="0" tIns="0" bIns="0">
-            <a:spAutoFit/>
-          </a:bodyPr>
-          <a:lstStyle/>
-          <a:p>
-            <a:pPr algn="l">
-              <a:lnSpc>
-                <a:spcPct val="115000"/>
-              </a:lnSpc>
-            </a:pPr>
-            <a:r>
-              <a:rPr sz="1100" b="0" i="0">
-                <a:solidFill>
-                  <a:srgbClr val="410F37"/>
-                </a:solidFill>
-                <a:latin typeface="Inter"/>
-              </a:rPr>
-              <a:t>Civil proceedings in Ireland continuing on behalf of sixteen plaintiffs; SEC pathway active. Mohib Ullah submission to the UN Special Rapporteur progressed (Hashmat feedback Q1).</a:t>
-            </a:r>
-          </a:p>
-        </p:txBody>
-      </p:sp>
-      <p:sp>
-        <p:nvSpPr>
-          <p:cNvPr id="10" name="TextBox 9"/>
-          <p:cNvSpPr txBox="1"/>
-          <p:nvPr/>
-        </p:nvSpPr>
-        <p:spPr>
-          <a:xfrm>
-            <a:off x="6400800" y="1828800"/>
-            <a:ext cx="5394960" cy="457200"/>
-          </a:xfrm>
-          <a:prstGeom prst="rect">
-            <a:avLst/>
-          </a:prstGeom>
-          <a:noFill/>
-        </p:spPr>
-        <p:txBody>
-          <a:bodyPr wrap="square" anchor="t" lIns="0" rIns="0" tIns="0" bIns="0">
-            <a:spAutoFit/>
-          </a:bodyPr>
-          <a:lstStyle/>
-          <a:p>
-            <a:pPr algn="l">
-              <a:lnSpc>
-                <a:spcPct val="115000"/>
-              </a:lnSpc>
-            </a:pPr>
-            <a:r>
-              <a:rPr sz="1400" b="1" i="0">
-                <a:solidFill>
-                  <a:srgbClr val="410F37"/>
-                </a:solidFill>
-                <a:latin typeface="Inter"/>
-              </a:rPr>
-              <a:t>Comms and external engagement</a:t>
-            </a:r>
-          </a:p>
-        </p:txBody>
-      </p:sp>
-      <p:sp>
-        <p:nvSpPr>
-          <p:cNvPr id="11" name="TextBox 10"/>
-          <p:cNvSpPr txBox="1"/>
-          <p:nvPr/>
-        </p:nvSpPr>
-        <p:spPr>
-          <a:xfrm>
-            <a:off x="6400800" y="2240280"/>
-            <a:ext cx="5394960" cy="1828800"/>
-          </a:xfrm>
-          <a:prstGeom prst="rect">
-            <a:avLst/>
-          </a:prstGeom>
-          <a:noFill/>
-        </p:spPr>
-        <p:txBody>
-          <a:bodyPr wrap="square" anchor="t" lIns="0" rIns="0" tIns="0" bIns="0">
-            <a:spAutoFit/>
-          </a:bodyPr>
-          <a:lstStyle/>
-          <a:p>
-            <a:pPr algn="l">
-              <a:lnSpc>
-                <a:spcPct val="115000"/>
-              </a:lnSpc>
-            </a:pPr>
-            <a:r>
-              <a:rPr sz="1100" b="0" i="0">
-                <a:solidFill>
-                  <a:srgbClr val="410F37"/>
-                </a:solidFill>
-                <a:latin typeface="Inter"/>
-              </a:rPr>
-              <a:t>Pitch notes drafted (April) for Rebecca Henschke (BBC World Service / BBC Eye) and Kristen Gelineau (AP). Foreign Correspondents-style convening late May with Aditi and Nazia. Geneva convening mid-May.</a:t>
+              <a:rPr sz="900" b="0" i="0">
+                <a:solidFill>
+                  <a:srgbClr val="96FF14"/>
+                </a:solidFill>
+                <a:latin typeface="Inter"/>
+              </a:rPr>
+              <a:t>hūmānus  ·  Q2 2026 Board Meeting</a:t>
             </a:r>
           </a:p>
         </p:txBody>
@@ -8778,123 +9656,6 @@
       <p:sp>
         <p:nvSpPr>
           <p:cNvPr id="12" name="TextBox 11"/>
-          <p:cNvSpPr txBox="1"/>
-          <p:nvPr/>
-        </p:nvSpPr>
-        <p:spPr>
-          <a:xfrm>
-            <a:off x="6400800" y="4572000"/>
-            <a:ext cx="5394960" cy="457200"/>
-          </a:xfrm>
-          <a:prstGeom prst="rect">
-            <a:avLst/>
-          </a:prstGeom>
-          <a:noFill/>
-        </p:spPr>
-        <p:txBody>
-          <a:bodyPr wrap="square" anchor="t" lIns="0" rIns="0" tIns="0" bIns="0">
-            <a:spAutoFit/>
-          </a:bodyPr>
-          <a:lstStyle/>
-          <a:p>
-            <a:pPr algn="l">
-              <a:lnSpc>
-                <a:spcPct val="115000"/>
-              </a:lnSpc>
-            </a:pPr>
-            <a:r>
-              <a:rPr sz="1400" b="1" i="0">
-                <a:solidFill>
-                  <a:srgbClr val="410F37"/>
-                </a:solidFill>
-                <a:latin typeface="Inter"/>
-              </a:rPr>
-              <a:t>Governance — Els onboarding</a:t>
-            </a:r>
-          </a:p>
-        </p:txBody>
-      </p:sp>
-      <p:sp>
-        <p:nvSpPr>
-          <p:cNvPr id="13" name="TextBox 12"/>
-          <p:cNvSpPr txBox="1"/>
-          <p:nvPr/>
-        </p:nvSpPr>
-        <p:spPr>
-          <a:xfrm>
-            <a:off x="6400800" y="4983480"/>
-            <a:ext cx="5394960" cy="1371600"/>
-          </a:xfrm>
-          <a:prstGeom prst="rect">
-            <a:avLst/>
-          </a:prstGeom>
-          <a:noFill/>
-        </p:spPr>
-        <p:txBody>
-          <a:bodyPr wrap="square" anchor="t" lIns="0" rIns="0" tIns="0" bIns="0">
-            <a:spAutoFit/>
-          </a:bodyPr>
-          <a:lstStyle/>
-          <a:p>
-            <a:pPr algn="l">
-              <a:lnSpc>
-                <a:spcPct val="115000"/>
-              </a:lnSpc>
-            </a:pPr>
-            <a:r>
-              <a:rPr sz="1100" b="0" i="0">
-                <a:solidFill>
-                  <a:srgbClr val="410F37"/>
-                </a:solidFill>
-                <a:latin typeface="Inter"/>
-              </a:rPr>
-              <a:t>Statutory director onboarding workstream completed April 2026: contracts, notary documents and statutes update, insurance cover with Els's broker. Closes Q1 action 9.</a:t>
-            </a:r>
-          </a:p>
-        </p:txBody>
-      </p:sp>
-      <p:sp>
-        <p:nvSpPr>
-          <p:cNvPr id="14" name="TextBox 13"/>
-          <p:cNvSpPr txBox="1"/>
-          <p:nvPr/>
-        </p:nvSpPr>
-        <p:spPr>
-          <a:xfrm>
-            <a:off x="640080" y="6492240"/>
-            <a:ext cx="7315200" cy="274320"/>
-          </a:xfrm>
-          <a:prstGeom prst="rect">
-            <a:avLst/>
-          </a:prstGeom>
-          <a:noFill/>
-        </p:spPr>
-        <p:txBody>
-          <a:bodyPr wrap="square" anchor="t" lIns="0" rIns="0" tIns="0" bIns="0">
-            <a:spAutoFit/>
-          </a:bodyPr>
-          <a:lstStyle/>
-          <a:p>
-            <a:pPr algn="l">
-              <a:lnSpc>
-                <a:spcPct val="115000"/>
-              </a:lnSpc>
-            </a:pPr>
-            <a:r>
-              <a:rPr sz="900" b="0" i="0">
-                <a:solidFill>
-                  <a:srgbClr val="410F37"/>
-                </a:solidFill>
-                <a:latin typeface="Inter"/>
-              </a:rPr>
-              <a:t>hūmānus  ·  Q2 2026 Board Meeting  ·  Operations &amp; Impact Update</a:t>
-            </a:r>
-          </a:p>
-        </p:txBody>
-      </p:sp>
-      <p:sp>
-        <p:nvSpPr>
-          <p:cNvPr id="15" name="TextBox 14"/>
           <p:cNvSpPr txBox="1"/>
           <p:nvPr/>
         </p:nvSpPr>
@@ -8922,11 +9683,11 @@
             <a:r>
               <a:rPr sz="900" b="0" i="0">
                 <a:solidFill>
-                  <a:srgbClr val="410F37"/>
-                </a:solidFill>
-                <a:latin typeface="Inter"/>
-              </a:rPr>
-              <a:t>8 / 10</a:t>
+                  <a:srgbClr val="96FF14"/>
+                </a:solidFill>
+                <a:latin typeface="Inter"/>
+              </a:rPr>
+              <a:t>8 / 11</a:t>
             </a:r>
           </a:p>
         </p:txBody>
@@ -9026,7 +9787,7 @@
                 </a:solidFill>
                 <a:latin typeface="Inter"/>
               </a:rPr>
-              <a:t>Strategic outlook and watch-items</a:t>
+              <a:t>Other significant work</a:t>
             </a:r>
           </a:p>
         </p:txBody>
@@ -9109,52 +9870,47 @@
                 </a:solidFill>
                 <a:latin typeface="Inter"/>
               </a:rPr>
-              <a:t>Things to keep in view between now and the Q3 meeting.</a:t>
-            </a:r>
-          </a:p>
-        </p:txBody>
-      </p:sp>
-      <p:sp>
-        <p:nvSpPr>
-          <p:cNvPr id="6" name="Rectangle 5"/>
-          <p:cNvSpPr/>
+              <a:t>Not externally project-funded, or peripheral to the funded portfolio.</a:t>
+            </a:r>
+          </a:p>
+        </p:txBody>
+      </p:sp>
+      <p:sp>
+        <p:nvSpPr>
+          <p:cNvPr id="6" name="TextBox 5"/>
+          <p:cNvSpPr txBox="1"/>
           <p:nvPr/>
         </p:nvSpPr>
         <p:spPr>
           <a:xfrm>
             <a:off x="640080" y="1828800"/>
-            <a:ext cx="137160" cy="777240"/>
-          </a:xfrm>
-          <a:prstGeom prst="rect">
-            <a:avLst/>
-          </a:prstGeom>
-          <a:solidFill>
-            <a:srgbClr val="E12D64"/>
-          </a:solidFill>
-          <a:ln>
-            <a:noFill/>
-          </a:ln>
-          <a:effectLst/>
-        </p:spPr>
-        <p:style>
-          <a:lnRef idx="1">
-            <a:schemeClr val="accent1"/>
-          </a:lnRef>
-          <a:fillRef idx="3">
-            <a:schemeClr val="accent1"/>
-          </a:fillRef>
-          <a:effectRef idx="2">
-            <a:schemeClr val="accent1"/>
-          </a:effectRef>
-          <a:fontRef idx="minor">
-            <a:schemeClr val="lt1"/>
-          </a:fontRef>
-        </p:style>
-        <p:txBody>
-          <a:bodyPr rtlCol="0" anchor="ctr"/>
-          <a:lstStyle/>
-          <a:p>
-            <a:pPr algn="ctr"/>
+            <a:ext cx="5394960" cy="457200"/>
+          </a:xfrm>
+          <a:prstGeom prst="rect">
+            <a:avLst/>
+          </a:prstGeom>
+          <a:noFill/>
+        </p:spPr>
+        <p:txBody>
+          <a:bodyPr wrap="square" anchor="t" lIns="0" rIns="0" tIns="0" bIns="0">
+            <a:spAutoFit/>
+          </a:bodyPr>
+          <a:lstStyle/>
+          <a:p>
+            <a:pPr algn="l">
+              <a:lnSpc>
+                <a:spcPct val="115000"/>
+              </a:lnSpc>
+            </a:pPr>
+            <a:r>
+              <a:rPr sz="1400" b="1" i="0">
+                <a:solidFill>
+                  <a:srgbClr val="410F37"/>
+                </a:solidFill>
+                <a:latin typeface="Inter"/>
+              </a:rPr>
+              <a:t>Adani / UniSuper / APRA strand</a:t>
+            </a:r>
           </a:p>
         </p:txBody>
       </p:sp>
@@ -9166,8 +9922,8 @@
         </p:nvSpPr>
         <p:spPr>
           <a:xfrm>
-            <a:off x="914400" y="1828800"/>
-            <a:ext cx="10698480" cy="365760"/>
+            <a:off x="640080" y="2240280"/>
+            <a:ext cx="5394960" cy="1828800"/>
           </a:xfrm>
           <a:prstGeom prst="rect">
             <a:avLst/>
@@ -9186,13 +9942,13 @@
               </a:lnSpc>
             </a:pPr>
             <a:r>
-              <a:rPr sz="1300" b="1" i="0">
+              <a:rPr sz="1100" b="0" i="0">
                 <a:solidFill>
                   <a:srgbClr val="410F37"/>
                 </a:solidFill>
                 <a:latin typeface="Inter"/>
               </a:rPr>
-              <a:t>Reserves and deficit-model donors</a:t>
+              <a:t>New and active workstream from March 2026. Includes APRA complaint work (Cbus deep-dive), Adani Investors briefings (Australian fiduciary case law, super-fund exposure to Adani / GQG), Adani Defence scoping, OFAC Iran civil-probe briefing, and a UniSuper PHD review. Substantial volume — Board may wish to take a dedicated update at a future meeting.</a:t>
             </a:r>
           </a:p>
         </p:txBody>
@@ -9205,8 +9961,8 @@
         </p:nvSpPr>
         <p:spPr>
           <a:xfrm>
-            <a:off x="914400" y="2148840"/>
-            <a:ext cx="10698480" cy="502920"/>
+            <a:off x="640080" y="4572000"/>
+            <a:ext cx="5394960" cy="457200"/>
           </a:xfrm>
           <a:prstGeom prst="rect">
             <a:avLst/>
@@ -9225,58 +9981,53 @@
               </a:lnSpc>
             </a:pPr>
             <a:r>
+              <a:rPr sz="1400" b="1" i="0">
+                <a:solidFill>
+                  <a:srgbClr val="410F37"/>
+                </a:solidFill>
+                <a:latin typeface="Inter"/>
+              </a:rPr>
+              <a:t>Meta Inc. accountability &amp; Mohib Ullah</a:t>
+            </a:r>
+          </a:p>
+        </p:txBody>
+      </p:sp>
+      <p:sp>
+        <p:nvSpPr>
+          <p:cNvPr id="9" name="TextBox 8"/>
+          <p:cNvSpPr txBox="1"/>
+          <p:nvPr/>
+        </p:nvSpPr>
+        <p:spPr>
+          <a:xfrm>
+            <a:off x="640080" y="4983480"/>
+            <a:ext cx="5394960" cy="1371600"/>
+          </a:xfrm>
+          <a:prstGeom prst="rect">
+            <a:avLst/>
+          </a:prstGeom>
+          <a:noFill/>
+        </p:spPr>
+        <p:txBody>
+          <a:bodyPr wrap="square" anchor="t" lIns="0" rIns="0" tIns="0" bIns="0">
+            <a:spAutoFit/>
+          </a:bodyPr>
+          <a:lstStyle/>
+          <a:p>
+            <a:pPr algn="l">
+              <a:lnSpc>
+                <a:spcPct val="115000"/>
+              </a:lnSpc>
+            </a:pPr>
+            <a:r>
               <a:rPr sz="1100" b="0" i="0">
                 <a:solidFill>
                   <a:srgbClr val="410F37"/>
                 </a:solidFill>
                 <a:latin typeface="Inter"/>
               </a:rPr>
-              <a:t>FCDO and Swiss reimburse in arrears; cash-flow discipline remains critical. Detail in papers 04 (Reserves Prognosis) and 05 (Y2D Grant Spend).</a:t>
-            </a:r>
-          </a:p>
-        </p:txBody>
-      </p:sp>
-      <p:sp>
-        <p:nvSpPr>
-          <p:cNvPr id="9" name="Rectangle 8"/>
-          <p:cNvSpPr/>
-          <p:nvPr/>
-        </p:nvSpPr>
-        <p:spPr>
-          <a:xfrm>
-            <a:off x="640080" y="2697480"/>
-            <a:ext cx="137160" cy="777240"/>
-          </a:xfrm>
-          <a:prstGeom prst="rect">
-            <a:avLst/>
-          </a:prstGeom>
-          <a:solidFill>
-            <a:srgbClr val="E12D64"/>
-          </a:solidFill>
-          <a:ln>
-            <a:noFill/>
-          </a:ln>
-          <a:effectLst/>
-        </p:spPr>
-        <p:style>
-          <a:lnRef idx="1">
-            <a:schemeClr val="accent1"/>
-          </a:lnRef>
-          <a:fillRef idx="3">
-            <a:schemeClr val="accent1"/>
-          </a:fillRef>
-          <a:effectRef idx="2">
-            <a:schemeClr val="accent1"/>
-          </a:effectRef>
-          <a:fontRef idx="minor">
-            <a:schemeClr val="lt1"/>
-          </a:fontRef>
-        </p:style>
-        <p:txBody>
-          <a:bodyPr rtlCol="0" anchor="ctr"/>
-          <a:lstStyle/>
-          <a:p>
-            <a:pPr algn="ctr"/>
+              <a:t>Civil proceedings in Ireland continuing on behalf of sixteen plaintiffs; SEC pathway active. Mohib Ullah submission to the UN Special Rapporteur progressed (Hashmat feedback Q1).</a:t>
+            </a:r>
           </a:p>
         </p:txBody>
       </p:sp>
@@ -9288,8 +10039,8 @@
         </p:nvSpPr>
         <p:spPr>
           <a:xfrm>
-            <a:off x="914400" y="2697480"/>
-            <a:ext cx="10698480" cy="365760"/>
+            <a:off x="6400800" y="1828800"/>
+            <a:ext cx="5394960" cy="457200"/>
           </a:xfrm>
           <a:prstGeom prst="rect">
             <a:avLst/>
@@ -9308,13 +10059,13 @@
               </a:lnSpc>
             </a:pPr>
             <a:r>
-              <a:rPr sz="1300" b="1" i="0">
+              <a:rPr sz="1400" b="1" i="0">
                 <a:solidFill>
                   <a:srgbClr val="410F37"/>
                 </a:solidFill>
                 <a:latin typeface="Inter"/>
               </a:rPr>
-              <a:t>VAI ↔ hūmānus entity transition</a:t>
+              <a:t>Comms and external engagement</a:t>
             </a:r>
           </a:p>
         </p:txBody>
@@ -9327,8 +10078,8 @@
         </p:nvSpPr>
         <p:spPr>
           <a:xfrm>
-            <a:off x="914400" y="3017520"/>
-            <a:ext cx="10698480" cy="502920"/>
+            <a:off x="6400800" y="2240280"/>
+            <a:ext cx="5394960" cy="1828800"/>
           </a:xfrm>
           <a:prstGeom prst="rect">
             <a:avLst/>
@@ -9353,52 +10104,47 @@
                 </a:solidFill>
                 <a:latin typeface="Inter"/>
               </a:rPr>
-              <a:t>Two active Swiss-funded workstreams straddle the transition — SDC Women's Dialogue closing out under VAI; Swiss/Stimson Arakan running under hūmānus.</a:t>
-            </a:r>
-          </a:p>
-        </p:txBody>
-      </p:sp>
-      <p:sp>
-        <p:nvSpPr>
-          <p:cNvPr id="12" name="Rectangle 11"/>
-          <p:cNvSpPr/>
-          <p:nvPr/>
-        </p:nvSpPr>
-        <p:spPr>
-          <a:xfrm>
-            <a:off x="640080" y="3566160"/>
-            <a:ext cx="137160" cy="777240"/>
-          </a:xfrm>
-          <a:prstGeom prst="rect">
-            <a:avLst/>
-          </a:prstGeom>
-          <a:solidFill>
-            <a:srgbClr val="E12D64"/>
-          </a:solidFill>
-          <a:ln>
-            <a:noFill/>
-          </a:ln>
-          <a:effectLst/>
-        </p:spPr>
-        <p:style>
-          <a:lnRef idx="1">
-            <a:schemeClr val="accent1"/>
-          </a:lnRef>
-          <a:fillRef idx="3">
-            <a:schemeClr val="accent1"/>
-          </a:fillRef>
-          <a:effectRef idx="2">
-            <a:schemeClr val="accent1"/>
-          </a:effectRef>
-          <a:fontRef idx="minor">
-            <a:schemeClr val="lt1"/>
-          </a:fontRef>
-        </p:style>
-        <p:txBody>
-          <a:bodyPr rtlCol="0" anchor="ctr"/>
-          <a:lstStyle/>
-          <a:p>
-            <a:pPr algn="ctr"/>
+              <a:t>Frontline Club panel hosted in London (2 April) — see preceding slide. Aditi and Nazia featured-speaker videos approved end-May for onward circulation. Pitch notes drafted (April) for Rebecca Henschke (BBC World Service / BBC Eye) and Kristen Gelineau (AP). Geneva convening mid-May.</a:t>
+            </a:r>
+          </a:p>
+        </p:txBody>
+      </p:sp>
+      <p:sp>
+        <p:nvSpPr>
+          <p:cNvPr id="12" name="TextBox 11"/>
+          <p:cNvSpPr txBox="1"/>
+          <p:nvPr/>
+        </p:nvSpPr>
+        <p:spPr>
+          <a:xfrm>
+            <a:off x="6400800" y="4572000"/>
+            <a:ext cx="5394960" cy="457200"/>
+          </a:xfrm>
+          <a:prstGeom prst="rect">
+            <a:avLst/>
+          </a:prstGeom>
+          <a:noFill/>
+        </p:spPr>
+        <p:txBody>
+          <a:bodyPr wrap="square" anchor="t" lIns="0" rIns="0" tIns="0" bIns="0">
+            <a:spAutoFit/>
+          </a:bodyPr>
+          <a:lstStyle/>
+          <a:p>
+            <a:pPr algn="l">
+              <a:lnSpc>
+                <a:spcPct val="115000"/>
+              </a:lnSpc>
+            </a:pPr>
+            <a:r>
+              <a:rPr sz="1400" b="1" i="0">
+                <a:solidFill>
+                  <a:srgbClr val="410F37"/>
+                </a:solidFill>
+                <a:latin typeface="Inter"/>
+              </a:rPr>
+              <a:t>Governance — Els onboarding</a:t>
+            </a:r>
           </a:p>
         </p:txBody>
       </p:sp>
@@ -9410,8 +10156,8 @@
         </p:nvSpPr>
         <p:spPr>
           <a:xfrm>
-            <a:off x="914400" y="3566160"/>
-            <a:ext cx="10698480" cy="365760"/>
+            <a:off x="6400800" y="4983480"/>
+            <a:ext cx="5394960" cy="1371600"/>
           </a:xfrm>
           <a:prstGeom prst="rect">
             <a:avLst/>
@@ -9430,13 +10176,13 @@
               </a:lnSpc>
             </a:pPr>
             <a:r>
-              <a:rPr sz="1300" b="1" i="0">
+              <a:rPr sz="1100" b="0" i="0">
                 <a:solidFill>
                   <a:srgbClr val="410F37"/>
                 </a:solidFill>
                 <a:latin typeface="Inter"/>
               </a:rPr>
-              <a:t>Bangladesh operating environment</a:t>
+              <a:t>Statutory director onboarding workstream completed April 2026: contracts, notary documents and statutes update, insurance cover with Els's broker. Closes Q1 action 9.</a:t>
             </a:r>
           </a:p>
         </p:txBody>
@@ -9444,289 +10190,6 @@
       <p:sp>
         <p:nvSpPr>
           <p:cNvPr id="14" name="TextBox 13"/>
-          <p:cNvSpPr txBox="1"/>
-          <p:nvPr/>
-        </p:nvSpPr>
-        <p:spPr>
-          <a:xfrm>
-            <a:off x="914400" y="3886200"/>
-            <a:ext cx="10698480" cy="502920"/>
-          </a:xfrm>
-          <a:prstGeom prst="rect">
-            <a:avLst/>
-          </a:prstGeom>
-          <a:noFill/>
-        </p:spPr>
-        <p:txBody>
-          <a:bodyPr wrap="square" anchor="t" lIns="0" rIns="0" tIns="0" bIns="0">
-            <a:spAutoFit/>
-          </a:bodyPr>
-          <a:lstStyle/>
-          <a:p>
-            <a:pPr algn="l">
-              <a:lnSpc>
-                <a:spcPct val="115000"/>
-              </a:lnSpc>
-            </a:pPr>
-            <a:r>
-              <a:rPr sz="1100" b="0" i="0">
-                <a:solidFill>
-                  <a:srgbClr val="410F37"/>
-                </a:solidFill>
-                <a:latin typeface="Inter"/>
-              </a:rPr>
-              <a:t>Political situation under the new government continues to shape Bangladesh dialogue and Stimson partnership delivery.</a:t>
-            </a:r>
-          </a:p>
-        </p:txBody>
-      </p:sp>
-      <p:sp>
-        <p:nvSpPr>
-          <p:cNvPr id="15" name="Rectangle 14"/>
-          <p:cNvSpPr/>
-          <p:nvPr/>
-        </p:nvSpPr>
-        <p:spPr>
-          <a:xfrm>
-            <a:off x="640080" y="4434840"/>
-            <a:ext cx="137160" cy="777240"/>
-          </a:xfrm>
-          <a:prstGeom prst="rect">
-            <a:avLst/>
-          </a:prstGeom>
-          <a:solidFill>
-            <a:srgbClr val="E12D64"/>
-          </a:solidFill>
-          <a:ln>
-            <a:noFill/>
-          </a:ln>
-          <a:effectLst/>
-        </p:spPr>
-        <p:style>
-          <a:lnRef idx="1">
-            <a:schemeClr val="accent1"/>
-          </a:lnRef>
-          <a:fillRef idx="3">
-            <a:schemeClr val="accent1"/>
-          </a:fillRef>
-          <a:effectRef idx="2">
-            <a:schemeClr val="accent1"/>
-          </a:effectRef>
-          <a:fontRef idx="minor">
-            <a:schemeClr val="lt1"/>
-          </a:fontRef>
-        </p:style>
-        <p:txBody>
-          <a:bodyPr rtlCol="0" anchor="ctr"/>
-          <a:lstStyle/>
-          <a:p>
-            <a:pPr algn="ctr"/>
-          </a:p>
-        </p:txBody>
-      </p:sp>
-      <p:sp>
-        <p:nvSpPr>
-          <p:cNvPr id="16" name="TextBox 15"/>
-          <p:cNvSpPr txBox="1"/>
-          <p:nvPr/>
-        </p:nvSpPr>
-        <p:spPr>
-          <a:xfrm>
-            <a:off x="914400" y="4434840"/>
-            <a:ext cx="10698480" cy="365760"/>
-          </a:xfrm>
-          <a:prstGeom prst="rect">
-            <a:avLst/>
-          </a:prstGeom>
-          <a:noFill/>
-        </p:spPr>
-        <p:txBody>
-          <a:bodyPr wrap="square" anchor="t" lIns="0" rIns="0" tIns="0" bIns="0">
-            <a:spAutoFit/>
-          </a:bodyPr>
-          <a:lstStyle/>
-          <a:p>
-            <a:pPr algn="l">
-              <a:lnSpc>
-                <a:spcPct val="115000"/>
-              </a:lnSpc>
-            </a:pPr>
-            <a:r>
-              <a:rPr sz="1300" b="1" i="0">
-                <a:solidFill>
-                  <a:srgbClr val="410F37"/>
-                </a:solidFill>
-                <a:latin typeface="Inter"/>
-              </a:rPr>
-              <a:t>Beyond 2029 / post-OSF horizon</a:t>
-            </a:r>
-          </a:p>
-        </p:txBody>
-      </p:sp>
-      <p:sp>
-        <p:nvSpPr>
-          <p:cNvPr id="17" name="TextBox 16"/>
-          <p:cNvSpPr txBox="1"/>
-          <p:nvPr/>
-        </p:nvSpPr>
-        <p:spPr>
-          <a:xfrm>
-            <a:off x="914400" y="4754880"/>
-            <a:ext cx="10698480" cy="502920"/>
-          </a:xfrm>
-          <a:prstGeom prst="rect">
-            <a:avLst/>
-          </a:prstGeom>
-          <a:noFill/>
-        </p:spPr>
-        <p:txBody>
-          <a:bodyPr wrap="square" anchor="t" lIns="0" rIns="0" tIns="0" bIns="0">
-            <a:spAutoFit/>
-          </a:bodyPr>
-          <a:lstStyle/>
-          <a:p>
-            <a:pPr algn="l">
-              <a:lnSpc>
-                <a:spcPct val="115000"/>
-              </a:lnSpc>
-            </a:pPr>
-            <a:r>
-              <a:rPr sz="1100" b="0" i="0">
-                <a:solidFill>
-                  <a:srgbClr val="410F37"/>
-                </a:solidFill>
-                <a:latin typeface="Inter"/>
-              </a:rPr>
-              <a:t>Picked up under agenda item 6 (strategic discussion) — matching ambition to a minimal-fundraising posture.</a:t>
-            </a:r>
-          </a:p>
-        </p:txBody>
-      </p:sp>
-      <p:sp>
-        <p:nvSpPr>
-          <p:cNvPr id="18" name="Rectangle 17"/>
-          <p:cNvSpPr/>
-          <p:nvPr/>
-        </p:nvSpPr>
-        <p:spPr>
-          <a:xfrm>
-            <a:off x="640080" y="5303520"/>
-            <a:ext cx="137160" cy="777240"/>
-          </a:xfrm>
-          <a:prstGeom prst="rect">
-            <a:avLst/>
-          </a:prstGeom>
-          <a:solidFill>
-            <a:srgbClr val="E12D64"/>
-          </a:solidFill>
-          <a:ln>
-            <a:noFill/>
-          </a:ln>
-          <a:effectLst/>
-        </p:spPr>
-        <p:style>
-          <a:lnRef idx="1">
-            <a:schemeClr val="accent1"/>
-          </a:lnRef>
-          <a:fillRef idx="3">
-            <a:schemeClr val="accent1"/>
-          </a:fillRef>
-          <a:effectRef idx="2">
-            <a:schemeClr val="accent1"/>
-          </a:effectRef>
-          <a:fontRef idx="minor">
-            <a:schemeClr val="lt1"/>
-          </a:fontRef>
-        </p:style>
-        <p:txBody>
-          <a:bodyPr rtlCol="0" anchor="ctr"/>
-          <a:lstStyle/>
-          <a:p>
-            <a:pPr algn="ctr"/>
-          </a:p>
-        </p:txBody>
-      </p:sp>
-      <p:sp>
-        <p:nvSpPr>
-          <p:cNvPr id="19" name="TextBox 18"/>
-          <p:cNvSpPr txBox="1"/>
-          <p:nvPr/>
-        </p:nvSpPr>
-        <p:spPr>
-          <a:xfrm>
-            <a:off x="914400" y="5303520"/>
-            <a:ext cx="10698480" cy="365760"/>
-          </a:xfrm>
-          <a:prstGeom prst="rect">
-            <a:avLst/>
-          </a:prstGeom>
-          <a:noFill/>
-        </p:spPr>
-        <p:txBody>
-          <a:bodyPr wrap="square" anchor="t" lIns="0" rIns="0" tIns="0" bIns="0">
-            <a:spAutoFit/>
-          </a:bodyPr>
-          <a:lstStyle/>
-          <a:p>
-            <a:pPr algn="l">
-              <a:lnSpc>
-                <a:spcPct val="115000"/>
-              </a:lnSpc>
-            </a:pPr>
-            <a:r>
-              <a:rPr sz="1300" b="1" i="0">
-                <a:solidFill>
-                  <a:srgbClr val="410F37"/>
-                </a:solidFill>
-                <a:latin typeface="Inter"/>
-              </a:rPr>
-              <a:t>Hiring posture</a:t>
-            </a:r>
-          </a:p>
-        </p:txBody>
-      </p:sp>
-      <p:sp>
-        <p:nvSpPr>
-          <p:cNvPr id="20" name="TextBox 19"/>
-          <p:cNvSpPr txBox="1"/>
-          <p:nvPr/>
-        </p:nvSpPr>
-        <p:spPr>
-          <a:xfrm>
-            <a:off x="914400" y="5623560"/>
-            <a:ext cx="10698480" cy="502920"/>
-          </a:xfrm>
-          <a:prstGeom prst="rect">
-            <a:avLst/>
-          </a:prstGeom>
-          <a:noFill/>
-        </p:spPr>
-        <p:txBody>
-          <a:bodyPr wrap="square" anchor="t" lIns="0" rIns="0" tIns="0" bIns="0">
-            <a:spAutoFit/>
-          </a:bodyPr>
-          <a:lstStyle/>
-          <a:p>
-            <a:pPr algn="l">
-              <a:lnSpc>
-                <a:spcPct val="115000"/>
-              </a:lnSpc>
-            </a:pPr>
-            <a:r>
-              <a:rPr sz="1100" b="0" i="0">
-                <a:solidFill>
-                  <a:srgbClr val="410F37"/>
-                </a:solidFill>
-                <a:latin typeface="Inter"/>
-              </a:rPr>
-              <a:t>Eva remains cautious on new permanent hires in the short term following Q1 reflection; no new joiners Feb–May 2026.</a:t>
-            </a:r>
-          </a:p>
-        </p:txBody>
-      </p:sp>
-      <p:sp>
-        <p:nvSpPr>
-          <p:cNvPr id="21" name="TextBox 20"/>
           <p:cNvSpPr txBox="1"/>
           <p:nvPr/>
         </p:nvSpPr>
@@ -9765,7 +10228,7 @@
       </p:sp>
       <p:sp>
         <p:nvSpPr>
-          <p:cNvPr id="22" name="TextBox 21"/>
+          <p:cNvPr id="15" name="TextBox 14"/>
           <p:cNvSpPr txBox="1"/>
           <p:nvPr/>
         </p:nvSpPr>
@@ -9797,7 +10260,7 @@
                 </a:solidFill>
                 <a:latin typeface="Inter"/>
               </a:rPr>
-              <a:t>9 / 10</a:t>
+              <a:t>9 / 11</a:t>
             </a:r>
           </a:p>
         </p:txBody>

</xml_diff>

<commit_message>
Reframe India work as core-funded; add BHR slide
Per Eva: India Rohingya legal-protection work is core-funded (no
OSF project grant), led by Arati Ranade; 8 cases commenced in West
Bengal with UP next. New slide 9 "Accountability for business and
human rights" pulls Meta, Adani/UniSuper/APRA, and Mohib Ullah under
a single programmatic framework. Governance and comms tiles folded
into strategic outlook. 11 slides. Refs CAP-199.

Co-Authored-By: Claude Opus 4.7 (1M context) <noreply@anthropic.com>
Co-authored-by: multica-agent <github@multica.ai>
</commit_message>
<xml_diff>
--- a/2026/Q2/08-ED-Operations-Impact-Y2D.pptx
+++ b/2026/Q2/08-ED-Operations-Impact-Y2D.pptx
@@ -3610,8 +3610,8 @@
         </p:nvSpPr>
         <p:spPr>
           <a:xfrm>
-            <a:off x="640080" y="1828800"/>
-            <a:ext cx="137160" cy="777240"/>
+            <a:off x="640080" y="1737360"/>
+            <a:ext cx="137160" cy="685800"/>
           </a:xfrm>
           <a:prstGeom prst="rect">
             <a:avLst/>
@@ -3654,8 +3654,8 @@
         </p:nvSpPr>
         <p:spPr>
           <a:xfrm>
-            <a:off x="914400" y="1828800"/>
-            <a:ext cx="10698480" cy="365760"/>
+            <a:off x="914400" y="1737360"/>
+            <a:ext cx="10698480" cy="320040"/>
           </a:xfrm>
           <a:prstGeom prst="rect">
             <a:avLst/>
@@ -3674,7 +3674,7 @@
               </a:lnSpc>
             </a:pPr>
             <a:r>
-              <a:rPr sz="1300" b="1" i="0">
+              <a:rPr sz="1200" b="1" i="0">
                 <a:solidFill>
                   <a:srgbClr val="410F37"/>
                 </a:solidFill>
@@ -3693,8 +3693,8 @@
         </p:nvSpPr>
         <p:spPr>
           <a:xfrm>
-            <a:off x="914400" y="2148840"/>
-            <a:ext cx="10698480" cy="502920"/>
+            <a:off x="914400" y="2011680"/>
+            <a:ext cx="10698480" cy="457200"/>
           </a:xfrm>
           <a:prstGeom prst="rect">
             <a:avLst/>
@@ -3713,7 +3713,7 @@
               </a:lnSpc>
             </a:pPr>
             <a:r>
-              <a:rPr sz="1100" b="0" i="0">
+              <a:rPr sz="1000" b="0" i="0">
                 <a:solidFill>
                   <a:srgbClr val="410F37"/>
                 </a:solidFill>
@@ -3732,8 +3732,8 @@
         </p:nvSpPr>
         <p:spPr>
           <a:xfrm>
-            <a:off x="640080" y="2697480"/>
-            <a:ext cx="137160" cy="777240"/>
+            <a:off x="640080" y="2487168"/>
+            <a:ext cx="137160" cy="685800"/>
           </a:xfrm>
           <a:prstGeom prst="rect">
             <a:avLst/>
@@ -3776,8 +3776,8 @@
         </p:nvSpPr>
         <p:spPr>
           <a:xfrm>
-            <a:off x="914400" y="2697480"/>
-            <a:ext cx="10698480" cy="365760"/>
+            <a:off x="914400" y="2487168"/>
+            <a:ext cx="10698480" cy="320040"/>
           </a:xfrm>
           <a:prstGeom prst="rect">
             <a:avLst/>
@@ -3796,7 +3796,7 @@
               </a:lnSpc>
             </a:pPr>
             <a:r>
-              <a:rPr sz="1300" b="1" i="0">
+              <a:rPr sz="1200" b="1" i="0">
                 <a:solidFill>
                   <a:srgbClr val="410F37"/>
                 </a:solidFill>
@@ -3815,8 +3815,8 @@
         </p:nvSpPr>
         <p:spPr>
           <a:xfrm>
-            <a:off x="914400" y="3017520"/>
-            <a:ext cx="10698480" cy="502920"/>
+            <a:off x="914400" y="2761488"/>
+            <a:ext cx="10698480" cy="457200"/>
           </a:xfrm>
           <a:prstGeom prst="rect">
             <a:avLst/>
@@ -3835,7 +3835,7 @@
               </a:lnSpc>
             </a:pPr>
             <a:r>
-              <a:rPr sz="1100" b="0" i="0">
+              <a:rPr sz="1000" b="0" i="0">
                 <a:solidFill>
                   <a:srgbClr val="410F37"/>
                 </a:solidFill>
@@ -3854,8 +3854,8 @@
         </p:nvSpPr>
         <p:spPr>
           <a:xfrm>
-            <a:off x="640080" y="3566160"/>
-            <a:ext cx="137160" cy="777240"/>
+            <a:off x="640080" y="3236976"/>
+            <a:ext cx="137160" cy="685800"/>
           </a:xfrm>
           <a:prstGeom prst="rect">
             <a:avLst/>
@@ -3898,8 +3898,8 @@
         </p:nvSpPr>
         <p:spPr>
           <a:xfrm>
-            <a:off x="914400" y="3566160"/>
-            <a:ext cx="10698480" cy="365760"/>
+            <a:off x="914400" y="3236976"/>
+            <a:ext cx="10698480" cy="320040"/>
           </a:xfrm>
           <a:prstGeom prst="rect">
             <a:avLst/>
@@ -3918,7 +3918,7 @@
               </a:lnSpc>
             </a:pPr>
             <a:r>
-              <a:rPr sz="1300" b="1" i="0">
+              <a:rPr sz="1200" b="1" i="0">
                 <a:solidFill>
                   <a:srgbClr val="410F37"/>
                 </a:solidFill>
@@ -3937,8 +3937,8 @@
         </p:nvSpPr>
         <p:spPr>
           <a:xfrm>
-            <a:off x="914400" y="3886200"/>
-            <a:ext cx="10698480" cy="502920"/>
+            <a:off x="914400" y="3511296"/>
+            <a:ext cx="10698480" cy="457200"/>
           </a:xfrm>
           <a:prstGeom prst="rect">
             <a:avLst/>
@@ -3957,7 +3957,7 @@
               </a:lnSpc>
             </a:pPr>
             <a:r>
-              <a:rPr sz="1100" b="0" i="0">
+              <a:rPr sz="1000" b="0" i="0">
                 <a:solidFill>
                   <a:srgbClr val="410F37"/>
                 </a:solidFill>
@@ -3976,8 +3976,8 @@
         </p:nvSpPr>
         <p:spPr>
           <a:xfrm>
-            <a:off x="640080" y="4434840"/>
-            <a:ext cx="137160" cy="777240"/>
+            <a:off x="640080" y="3986784"/>
+            <a:ext cx="137160" cy="685800"/>
           </a:xfrm>
           <a:prstGeom prst="rect">
             <a:avLst/>
@@ -4020,8 +4020,8 @@
         </p:nvSpPr>
         <p:spPr>
           <a:xfrm>
-            <a:off x="914400" y="4434840"/>
-            <a:ext cx="10698480" cy="365760"/>
+            <a:off x="914400" y="3986784"/>
+            <a:ext cx="10698480" cy="320040"/>
           </a:xfrm>
           <a:prstGeom prst="rect">
             <a:avLst/>
@@ -4040,7 +4040,7 @@
               </a:lnSpc>
             </a:pPr>
             <a:r>
-              <a:rPr sz="1300" b="1" i="0">
+              <a:rPr sz="1200" b="1" i="0">
                 <a:solidFill>
                   <a:srgbClr val="410F37"/>
                 </a:solidFill>
@@ -4059,8 +4059,8 @@
         </p:nvSpPr>
         <p:spPr>
           <a:xfrm>
-            <a:off x="914400" y="4754880"/>
-            <a:ext cx="10698480" cy="502920"/>
+            <a:off x="914400" y="4261104"/>
+            <a:ext cx="10698480" cy="457200"/>
           </a:xfrm>
           <a:prstGeom prst="rect">
             <a:avLst/>
@@ -4079,7 +4079,7 @@
               </a:lnSpc>
             </a:pPr>
             <a:r>
-              <a:rPr sz="1100" b="0" i="0">
+              <a:rPr sz="1000" b="0" i="0">
                 <a:solidFill>
                   <a:srgbClr val="410F37"/>
                 </a:solidFill>
@@ -4098,8 +4098,8 @@
         </p:nvSpPr>
         <p:spPr>
           <a:xfrm>
-            <a:off x="640080" y="5303520"/>
-            <a:ext cx="137160" cy="777240"/>
+            <a:off x="640080" y="4736592"/>
+            <a:ext cx="137160" cy="685800"/>
           </a:xfrm>
           <a:prstGeom prst="rect">
             <a:avLst/>
@@ -4142,8 +4142,8 @@
         </p:nvSpPr>
         <p:spPr>
           <a:xfrm>
-            <a:off x="914400" y="5303520"/>
-            <a:ext cx="10698480" cy="365760"/>
+            <a:off x="914400" y="4736592"/>
+            <a:ext cx="10698480" cy="320040"/>
           </a:xfrm>
           <a:prstGeom prst="rect">
             <a:avLst/>
@@ -4162,7 +4162,7 @@
               </a:lnSpc>
             </a:pPr>
             <a:r>
-              <a:rPr sz="1300" b="1" i="0">
+              <a:rPr sz="1200" b="1" i="0">
                 <a:solidFill>
                   <a:srgbClr val="410F37"/>
                 </a:solidFill>
@@ -4181,8 +4181,8 @@
         </p:nvSpPr>
         <p:spPr>
           <a:xfrm>
-            <a:off x="914400" y="5623560"/>
-            <a:ext cx="10698480" cy="502920"/>
+            <a:off x="914400" y="5010912"/>
+            <a:ext cx="10698480" cy="457200"/>
           </a:xfrm>
           <a:prstGeom prst="rect">
             <a:avLst/>
@@ -4201,20 +4201,142 @@
               </a:lnSpc>
             </a:pPr>
             <a:r>
-              <a:rPr sz="1100" b="0" i="0">
+              <a:rPr sz="1000" b="0" i="0">
                 <a:solidFill>
                   <a:srgbClr val="410F37"/>
                 </a:solidFill>
                 <a:latin typeface="Inter"/>
               </a:rPr>
-              <a:t>Eva remains cautious on new permanent hires in the short term following Q1 reflection; no new joiners Feb–May 2026.</a:t>
-            </a:r>
-          </a:p>
-        </p:txBody>
-      </p:sp>
-      <p:sp>
-        <p:nvSpPr>
-          <p:cNvPr id="21" name="TextBox 20"/>
+              <a:t>Cautious on new permanent hires after Q1 reflection; no new joiners Feb–May 2026.</a:t>
+            </a:r>
+          </a:p>
+        </p:txBody>
+      </p:sp>
+      <p:sp>
+        <p:nvSpPr>
+          <p:cNvPr id="21" name="Rectangle 20"/>
+          <p:cNvSpPr/>
+          <p:nvPr/>
+        </p:nvSpPr>
+        <p:spPr>
+          <a:xfrm>
+            <a:off x="640080" y="5486400"/>
+            <a:ext cx="137160" cy="685800"/>
+          </a:xfrm>
+          <a:prstGeom prst="rect">
+            <a:avLst/>
+          </a:prstGeom>
+          <a:solidFill>
+            <a:srgbClr val="E12D64"/>
+          </a:solidFill>
+          <a:ln>
+            <a:noFill/>
+          </a:ln>
+          <a:effectLst/>
+        </p:spPr>
+        <p:style>
+          <a:lnRef idx="1">
+            <a:schemeClr val="accent1"/>
+          </a:lnRef>
+          <a:fillRef idx="3">
+            <a:schemeClr val="accent1"/>
+          </a:fillRef>
+          <a:effectRef idx="2">
+            <a:schemeClr val="accent1"/>
+          </a:effectRef>
+          <a:fontRef idx="minor">
+            <a:schemeClr val="lt1"/>
+          </a:fontRef>
+        </p:style>
+        <p:txBody>
+          <a:bodyPr rtlCol="0" anchor="ctr"/>
+          <a:lstStyle/>
+          <a:p>
+            <a:pPr algn="ctr"/>
+          </a:p>
+        </p:txBody>
+      </p:sp>
+      <p:sp>
+        <p:nvSpPr>
+          <p:cNvPr id="22" name="TextBox 21"/>
+          <p:cNvSpPr txBox="1"/>
+          <p:nvPr/>
+        </p:nvSpPr>
+        <p:spPr>
+          <a:xfrm>
+            <a:off x="914400" y="5486400"/>
+            <a:ext cx="10698480" cy="320040"/>
+          </a:xfrm>
+          <a:prstGeom prst="rect">
+            <a:avLst/>
+          </a:prstGeom>
+          <a:noFill/>
+        </p:spPr>
+        <p:txBody>
+          <a:bodyPr wrap="square" anchor="t" lIns="0" rIns="0" tIns="0" bIns="0">
+            <a:spAutoFit/>
+          </a:bodyPr>
+          <a:lstStyle/>
+          <a:p>
+            <a:pPr algn="l">
+              <a:lnSpc>
+                <a:spcPct val="115000"/>
+              </a:lnSpc>
+            </a:pPr>
+            <a:r>
+              <a:rPr sz="1200" b="1" i="0">
+                <a:solidFill>
+                  <a:srgbClr val="410F37"/>
+                </a:solidFill>
+                <a:latin typeface="Inter"/>
+              </a:rPr>
+              <a:t>Governance and external engagement</a:t>
+            </a:r>
+          </a:p>
+        </p:txBody>
+      </p:sp>
+      <p:sp>
+        <p:nvSpPr>
+          <p:cNvPr id="23" name="TextBox 22"/>
+          <p:cNvSpPr txBox="1"/>
+          <p:nvPr/>
+        </p:nvSpPr>
+        <p:spPr>
+          <a:xfrm>
+            <a:off x="914400" y="5760720"/>
+            <a:ext cx="10698480" cy="457200"/>
+          </a:xfrm>
+          <a:prstGeom prst="rect">
+            <a:avLst/>
+          </a:prstGeom>
+          <a:noFill/>
+        </p:spPr>
+        <p:txBody>
+          <a:bodyPr wrap="square" anchor="t" lIns="0" rIns="0" tIns="0" bIns="0">
+            <a:spAutoFit/>
+          </a:bodyPr>
+          <a:lstStyle/>
+          <a:p>
+            <a:pPr algn="l">
+              <a:lnSpc>
+                <a:spcPct val="115000"/>
+              </a:lnSpc>
+            </a:pPr>
+            <a:r>
+              <a:rPr sz="1000" b="0" i="0">
+                <a:solidFill>
+                  <a:srgbClr val="410F37"/>
+                </a:solidFill>
+                <a:latin typeface="Inter"/>
+              </a:rPr>
+              <a:t>Els onboarding closed Q1 action 9 (contracts, notary, statutes, insurance — April). BBC and AP pitches drafted in April; Geneva convening mid-May. Frontline Club post-production complete.</a:t>
+            </a:r>
+          </a:p>
+        </p:txBody>
+      </p:sp>
+      <p:sp>
+        <p:nvSpPr>
+          <p:cNvPr id="24" name="TextBox 23"/>
           <p:cNvSpPr txBox="1"/>
           <p:nvPr/>
         </p:nvSpPr>
@@ -4253,7 +4375,7 @@
       </p:sp>
       <p:sp>
         <p:nvSpPr>
-          <p:cNvPr id="22" name="TextBox 21"/>
+          <p:cNvPr id="25" name="TextBox 24"/>
           <p:cNvSpPr txBox="1"/>
           <p:nvPr/>
         </p:nvSpPr>
@@ -5956,7 +6078,7 @@
                 </a:solidFill>
                 <a:latin typeface="Inter"/>
               </a:rPr>
-              <a:t>OSF South Asia — Rohingya in India</a:t>
+              <a:t>Rohingya in India — legal protection</a:t>
             </a:r>
           </a:p>
         </p:txBody>
@@ -5995,7 +6117,7 @@
                 </a:solidFill>
                 <a:latin typeface="Inter"/>
               </a:rPr>
-              <a:t>Open Society Foundations</a:t>
+              <a:t>Core funding</a:t>
             </a:r>
           </a:p>
         </p:txBody>
@@ -6034,7 +6156,7 @@
                 </a:solidFill>
                 <a:latin typeface="Inter"/>
               </a:rPr>
-              <a:t>$300k received Jan 2026; India litigation, RSU partnership, HDCO/Bridging Changes consultation in flight.</a:t>
+              <a:t>Lead: Arati Ranade. 8 cases commenced in West Bengal; UP next. RSU and Bridging Changes / HDCO consultation in flight.</a:t>
             </a:r>
           </a:p>
         </p:txBody>
@@ -6278,7 +6400,7 @@
                 </a:solidFill>
                 <a:latin typeface="Inter"/>
               </a:rPr>
-              <a:t>Adani / UniSuper / APRA</a:t>
+              <a:t>Accountability for business and human rights</a:t>
             </a:r>
           </a:p>
         </p:txBody>
@@ -6317,7 +6439,7 @@
                 </a:solidFill>
                 <a:latin typeface="Inter"/>
               </a:rPr>
-              <a:t>Self-directed (no external grant)</a:t>
+              <a:t>Core funding</a:t>
             </a:r>
           </a:p>
         </p:txBody>
@@ -6356,7 +6478,7 @@
                 </a:solidFill>
                 <a:latin typeface="Inter"/>
               </a:rPr>
-              <a:t>New strand from March 2026; substantial volume.</a:t>
+              <a:t>Meta Inc. proceedings; Adani / UniSuper / APRA strand (new from March); Mohib Ullah accountability continuing.</a:t>
             </a:r>
           </a:p>
         </p:txBody>
@@ -6439,7 +6561,7 @@
                 </a:solidFill>
                 <a:latin typeface="Inter"/>
               </a:rPr>
-              <a:t>Meta Inc. accountability</a:t>
+              <a:t>Public engagement</a:t>
             </a:r>
           </a:p>
         </p:txBody>
@@ -6478,7 +6600,7 @@
                 </a:solidFill>
                 <a:latin typeface="Inter"/>
               </a:rPr>
-              <a:t>Self-directed</a:t>
+              <a:t>Core funding</a:t>
             </a:r>
           </a:p>
         </p:txBody>
@@ -6517,7 +6639,7 @@
                 </a:solidFill>
                 <a:latin typeface="Inter"/>
               </a:rPr>
-              <a:t>Civil proceedings in Ireland continuing; SEC pathway live.</a:t>
+              <a:t>Frontline Club London panel (2 April 2026); Aditi and Nazia speaker videos; BBC and AP pitches; Geneva mid-May.</a:t>
             </a:r>
           </a:p>
         </p:txBody>
@@ -7988,7 +8110,7 @@
                 </a:solidFill>
                 <a:latin typeface="Inter"/>
               </a:rPr>
-              <a:t>OSF South Asia — Rohingya in India</a:t>
+              <a:t>Rohingya in India — legal protection</a:t>
             </a:r>
           </a:p>
         </p:txBody>
@@ -8071,7 +8193,7 @@
                 </a:solidFill>
                 <a:latin typeface="Inter"/>
               </a:rPr>
-              <a:t>Open Society Foundations  ·  USD 300,000 grant received January 2026</a:t>
+              <a:t>Core funded  ·  no project grant  ·  Lead: Arati Ranade, India Programme Manager</a:t>
             </a:r>
           </a:p>
         </p:txBody>
@@ -8084,7 +8206,7 @@
         </p:nvSpPr>
         <p:spPr>
           <a:xfrm>
-            <a:off x="640080" y="1828800"/>
+            <a:off x="640080" y="1874519"/>
             <a:ext cx="10972800" cy="457200"/>
           </a:xfrm>
           <a:prstGeom prst="rect">
@@ -8110,7 +8232,7 @@
                 </a:solidFill>
                 <a:latin typeface="Inter"/>
               </a:rPr>
-              <a:t>What the grant supports</a:t>
+              <a:t>What the strand is</a:t>
             </a:r>
           </a:p>
         </p:txBody>
@@ -8123,7 +8245,7 @@
         </p:nvSpPr>
         <p:spPr>
           <a:xfrm>
-            <a:off x="640080" y="2240280"/>
+            <a:off x="640080" y="2286000"/>
             <a:ext cx="10972800" cy="1097280"/>
           </a:xfrm>
           <a:prstGeom prst="rect">
@@ -8149,7 +8271,7 @@
                 </a:solidFill>
                 <a:latin typeface="Inter"/>
               </a:rPr>
-              <a:t>Strategic work on Rohingya in India: protecting detained refugees through legal intervention, building a cross-state network of lawyers, and feeding evidence and analysis into wider Rohingya advocacy.</a:t>
+              <a:t>Direct legal intervention for detained Rohingya refugees in India, building a cross-state network of lawyers and an evidentiary base on detention and deportation patterns. Funded from core — no donor restriction on case selection or strategy.</a:t>
             </a:r>
           </a:p>
         </p:txBody>
@@ -8162,7 +8284,7 @@
         </p:nvSpPr>
         <p:spPr>
           <a:xfrm>
-            <a:off x="640080" y="3383280"/>
+            <a:off x="640080" y="3429000"/>
             <a:ext cx="10972800" cy="457200"/>
           </a:xfrm>
           <a:prstGeom prst="rect">
@@ -8201,7 +8323,7 @@
         </p:nvSpPr>
         <p:spPr>
           <a:xfrm>
-            <a:off x="640080" y="3913632"/>
+            <a:off x="640080" y="3959352"/>
             <a:ext cx="109728" cy="109728"/>
           </a:xfrm>
           <a:prstGeom prst="rect">
@@ -8245,7 +8367,7 @@
         </p:nvSpPr>
         <p:spPr>
           <a:xfrm>
-            <a:off x="914400" y="3794760"/>
+            <a:off x="914400" y="3840480"/>
             <a:ext cx="10698480" cy="457200"/>
           </a:xfrm>
           <a:prstGeom prst="rect">
@@ -8271,7 +8393,7 @@
                 </a:solidFill>
                 <a:latin typeface="Inter"/>
               </a:rPr>
-              <a:t>India detention database — partnership with the Azadi Project; live and in active use.</a:t>
+              <a:t>Litigation — 8 cases commenced in West Bengal; UP scoping under way as the next state to open up.</a:t>
             </a:r>
           </a:p>
         </p:txBody>
@@ -8284,7 +8406,7 @@
         </p:nvSpPr>
         <p:spPr>
           <a:xfrm>
-            <a:off x="640080" y="4370832"/>
+            <a:off x="640080" y="4416552"/>
             <a:ext cx="109728" cy="109728"/>
           </a:xfrm>
           <a:prstGeom prst="rect">
@@ -8328,7 +8450,7 @@
         </p:nvSpPr>
         <p:spPr>
           <a:xfrm>
-            <a:off x="914400" y="4251960"/>
+            <a:off x="914400" y="4297680"/>
             <a:ext cx="10698480" cy="457200"/>
           </a:xfrm>
           <a:prstGeom prst="rect">
@@ -8354,7 +8476,7 @@
                 </a:solidFill>
                 <a:latin typeface="Inter"/>
               </a:rPr>
-              <a:t>Litigation strand — habeas corpus drafting and bail applications under way since January; RTI / petitioner-search work continuing; lawyer outreach in J&amp;K; quarterly report of developments commissioned end-March.</a:t>
+              <a:t>Supporting work — habeas corpus drafts, bail applications, RTI / petitioner-search, lawyer outreach in J&amp;K; quarterly developments report commissioned end-March.</a:t>
             </a:r>
           </a:p>
         </p:txBody>
@@ -8367,7 +8489,7 @@
         </p:nvSpPr>
         <p:spPr>
           <a:xfrm>
-            <a:off x="640080" y="4828032"/>
+            <a:off x="640080" y="4873752"/>
             <a:ext cx="109728" cy="109728"/>
           </a:xfrm>
           <a:prstGeom prst="rect">
@@ -8411,7 +8533,7 @@
         </p:nvSpPr>
         <p:spPr>
           <a:xfrm>
-            <a:off x="914400" y="4709160"/>
+            <a:off x="914400" y="4754880"/>
             <a:ext cx="10698480" cy="457200"/>
           </a:xfrm>
           <a:prstGeom prst="rect">
@@ -8437,7 +8559,7 @@
                 </a:solidFill>
                 <a:latin typeface="Inter"/>
               </a:rPr>
-              <a:t>Rohingya Student Union — stakeholder analysis partnership; formal kick-off and work-plan location to be confirmed at the meeting.</a:t>
+              <a:t>India detention database — continuing partnership with the Azadi Project; remains live and in active use.</a:t>
             </a:r>
           </a:p>
         </p:txBody>
@@ -8450,7 +8572,7 @@
         </p:nvSpPr>
         <p:spPr>
           <a:xfrm>
-            <a:off x="640080" y="5285232"/>
+            <a:off x="640080" y="5330952"/>
             <a:ext cx="109728" cy="109728"/>
           </a:xfrm>
           <a:prstGeom prst="rect">
@@ -8494,7 +8616,7 @@
         </p:nvSpPr>
         <p:spPr>
           <a:xfrm>
-            <a:off x="914400" y="5166360"/>
+            <a:off x="914400" y="5212080"/>
             <a:ext cx="10698480" cy="457200"/>
           </a:xfrm>
           <a:prstGeom prst="rect">
@@ -8520,6 +8642,89 @@
                 </a:solidFill>
                 <a:latin typeface="Inter"/>
               </a:rPr>
+              <a:t>Rohingya Student Union — stakeholder-analysis partnership in flight; formal kick-off status to be confirmed at the meeting.</a:t>
+            </a:r>
+          </a:p>
+        </p:txBody>
+      </p:sp>
+      <p:sp>
+        <p:nvSpPr>
+          <p:cNvPr id="17" name="Rectangle 16"/>
+          <p:cNvSpPr/>
+          <p:nvPr/>
+        </p:nvSpPr>
+        <p:spPr>
+          <a:xfrm>
+            <a:off x="640080" y="5788152"/>
+            <a:ext cx="109728" cy="109728"/>
+          </a:xfrm>
+          <a:prstGeom prst="rect">
+            <a:avLst/>
+          </a:prstGeom>
+          <a:solidFill>
+            <a:srgbClr val="96FF14"/>
+          </a:solidFill>
+          <a:ln>
+            <a:noFill/>
+          </a:ln>
+          <a:effectLst/>
+        </p:spPr>
+        <p:style>
+          <a:lnRef idx="1">
+            <a:schemeClr val="accent1"/>
+          </a:lnRef>
+          <a:fillRef idx="3">
+            <a:schemeClr val="accent1"/>
+          </a:fillRef>
+          <a:effectRef idx="2">
+            <a:schemeClr val="accent1"/>
+          </a:effectRef>
+          <a:fontRef idx="minor">
+            <a:schemeClr val="lt1"/>
+          </a:fontRef>
+        </p:style>
+        <p:txBody>
+          <a:bodyPr rtlCol="0" anchor="ctr"/>
+          <a:lstStyle/>
+          <a:p>
+            <a:pPr algn="ctr"/>
+          </a:p>
+        </p:txBody>
+      </p:sp>
+      <p:sp>
+        <p:nvSpPr>
+          <p:cNvPr id="18" name="TextBox 17"/>
+          <p:cNvSpPr txBox="1"/>
+          <p:nvPr/>
+        </p:nvSpPr>
+        <p:spPr>
+          <a:xfrm>
+            <a:off x="914400" y="5669280"/>
+            <a:ext cx="10698480" cy="457200"/>
+          </a:xfrm>
+          <a:prstGeom prst="rect">
+            <a:avLst/>
+          </a:prstGeom>
+          <a:noFill/>
+        </p:spPr>
+        <p:txBody>
+          <a:bodyPr wrap="square" anchor="t" lIns="0" rIns="0" tIns="0" bIns="0">
+            <a:spAutoFit/>
+          </a:bodyPr>
+          <a:lstStyle/>
+          <a:p>
+            <a:pPr algn="l">
+              <a:lnSpc>
+                <a:spcPct val="125000"/>
+              </a:lnSpc>
+            </a:pPr>
+            <a:r>
+              <a:rPr sz="1300" b="0" i="0">
+                <a:solidFill>
+                  <a:srgbClr val="410F37"/>
+                </a:solidFill>
+                <a:latin typeface="Inter"/>
+              </a:rPr>
               <a:t>Bridging Changes Coalition / HDCO — Rohingya-in-India closed-door consultation in flight (scoped Q1); date and outputs to be confirmed at the meeting.</a:t>
             </a:r>
           </a:p>
@@ -8527,7 +8732,7 @@
       </p:sp>
       <p:sp>
         <p:nvSpPr>
-          <p:cNvPr id="17" name="TextBox 16"/>
+          <p:cNvPr id="19" name="TextBox 18"/>
           <p:cNvSpPr txBox="1"/>
           <p:nvPr/>
         </p:nvSpPr>
@@ -8566,7 +8771,7 @@
       </p:sp>
       <p:sp>
         <p:nvSpPr>
-          <p:cNvPr id="18" name="TextBox 17"/>
+          <p:cNvPr id="20" name="TextBox 19"/>
           <p:cNvSpPr txBox="1"/>
           <p:nvPr/>
         </p:nvSpPr>
@@ -9787,7 +9992,7 @@
                 </a:solidFill>
                 <a:latin typeface="Inter"/>
               </a:rPr>
-              <a:t>Other significant work</a:t>
+              <a:t>Accountability for business and human rights</a:t>
             </a:r>
           </a:p>
         </p:txBody>
@@ -9870,7 +10075,7 @@
                 </a:solidFill>
                 <a:latin typeface="Inter"/>
               </a:rPr>
-              <a:t>Not externally project-funded, or peripheral to the funded portfolio.</a:t>
+              <a:t>Core funded  ·  programmatic framework for our corporate-accountability work</a:t>
             </a:r>
           </a:p>
         </p:txBody>
@@ -9883,8 +10088,8 @@
         </p:nvSpPr>
         <p:spPr>
           <a:xfrm>
-            <a:off x="640080" y="1828800"/>
-            <a:ext cx="5394960" cy="457200"/>
+            <a:off x="640080" y="1874519"/>
+            <a:ext cx="10972800" cy="457200"/>
           </a:xfrm>
           <a:prstGeom prst="rect">
             <a:avLst/>
@@ -9903,13 +10108,13 @@
               </a:lnSpc>
             </a:pPr>
             <a:r>
-              <a:rPr sz="1400" b="1" i="0">
+              <a:rPr sz="1500" b="1" i="0">
                 <a:solidFill>
                   <a:srgbClr val="410F37"/>
                 </a:solidFill>
                 <a:latin typeface="Inter"/>
               </a:rPr>
-              <a:t>Adani / UniSuper / APRA strand</a:t>
+              <a:t>The framework</a:t>
             </a:r>
           </a:p>
         </p:txBody>
@@ -9922,8 +10127,8 @@
         </p:nvSpPr>
         <p:spPr>
           <a:xfrm>
-            <a:off x="640080" y="2240280"/>
-            <a:ext cx="5394960" cy="1828800"/>
+            <a:off x="640080" y="2286000"/>
+            <a:ext cx="10972800" cy="914400"/>
           </a:xfrm>
           <a:prstGeom prst="rect">
             <a:avLst/>
@@ -9942,27 +10147,144 @@
               </a:lnSpc>
             </a:pPr>
             <a:r>
+              <a:rPr sz="1200" b="0" i="0">
+                <a:solidFill>
+                  <a:srgbClr val="410F37"/>
+                </a:solidFill>
+                <a:latin typeface="Inter"/>
+              </a:rPr>
+              <a:t>Bringing together our work that holds business actors accountable for contribution to, or benefit from, serious international crimes — across litigation, regulatory complaint, and investor-facing advocacy.</a:t>
+            </a:r>
+          </a:p>
+        </p:txBody>
+      </p:sp>
+      <p:sp>
+        <p:nvSpPr>
+          <p:cNvPr id="8" name="TextBox 7"/>
+          <p:cNvSpPr txBox="1"/>
+          <p:nvPr/>
+        </p:nvSpPr>
+        <p:spPr>
+          <a:xfrm>
+            <a:off x="640080" y="3200400"/>
+            <a:ext cx="10972800" cy="457200"/>
+          </a:xfrm>
+          <a:prstGeom prst="rect">
+            <a:avLst/>
+          </a:prstGeom>
+          <a:noFill/>
+        </p:spPr>
+        <p:txBody>
+          <a:bodyPr wrap="square" anchor="t" lIns="0" rIns="0" tIns="0" bIns="0">
+            <a:spAutoFit/>
+          </a:bodyPr>
+          <a:lstStyle/>
+          <a:p>
+            <a:pPr algn="l">
+              <a:lnSpc>
+                <a:spcPct val="115000"/>
+              </a:lnSpc>
+            </a:pPr>
+            <a:r>
+              <a:rPr sz="1500" b="1" i="0">
+                <a:solidFill>
+                  <a:srgbClr val="410F37"/>
+                </a:solidFill>
+                <a:latin typeface="Inter"/>
+              </a:rPr>
+              <a:t>Active workstreams</a:t>
+            </a:r>
+          </a:p>
+        </p:txBody>
+      </p:sp>
+      <p:sp>
+        <p:nvSpPr>
+          <p:cNvPr id="9" name="TextBox 8"/>
+          <p:cNvSpPr txBox="1"/>
+          <p:nvPr/>
+        </p:nvSpPr>
+        <p:spPr>
+          <a:xfrm>
+            <a:off x="640080" y="3657600"/>
+            <a:ext cx="5394960" cy="365760"/>
+          </a:xfrm>
+          <a:prstGeom prst="rect">
+            <a:avLst/>
+          </a:prstGeom>
+          <a:noFill/>
+        </p:spPr>
+        <p:txBody>
+          <a:bodyPr wrap="square" anchor="t" lIns="0" rIns="0" tIns="0" bIns="0">
+            <a:spAutoFit/>
+          </a:bodyPr>
+          <a:lstStyle/>
+          <a:p>
+            <a:pPr algn="l">
+              <a:lnSpc>
+                <a:spcPct val="115000"/>
+              </a:lnSpc>
+            </a:pPr>
+            <a:r>
+              <a:rPr sz="1300" b="1" i="0">
+                <a:solidFill>
+                  <a:srgbClr val="410F37"/>
+                </a:solidFill>
+                <a:latin typeface="Inter"/>
+              </a:rPr>
+              <a:t>Meta Inc.</a:t>
+            </a:r>
+          </a:p>
+        </p:txBody>
+      </p:sp>
+      <p:sp>
+        <p:nvSpPr>
+          <p:cNvPr id="10" name="TextBox 9"/>
+          <p:cNvSpPr txBox="1"/>
+          <p:nvPr/>
+        </p:nvSpPr>
+        <p:spPr>
+          <a:xfrm>
+            <a:off x="640080" y="4023360"/>
+            <a:ext cx="5394960" cy="1280160"/>
+          </a:xfrm>
+          <a:prstGeom prst="rect">
+            <a:avLst/>
+          </a:prstGeom>
+          <a:noFill/>
+        </p:spPr>
+        <p:txBody>
+          <a:bodyPr wrap="square" anchor="t" lIns="0" rIns="0" tIns="0" bIns="0">
+            <a:spAutoFit/>
+          </a:bodyPr>
+          <a:lstStyle/>
+          <a:p>
+            <a:pPr algn="l">
+              <a:lnSpc>
+                <a:spcPct val="115000"/>
+              </a:lnSpc>
+            </a:pPr>
+            <a:r>
               <a:rPr sz="1100" b="0" i="0">
                 <a:solidFill>
                   <a:srgbClr val="410F37"/>
                 </a:solidFill>
                 <a:latin typeface="Inter"/>
               </a:rPr>
-              <a:t>New and active workstream from March 2026. Includes APRA complaint work (Cbus deep-dive), Adani Investors briefings (Australian fiduciary case law, super-fund exposure to Adani / GQG), Adani Defence scoping, OFAC Iran civil-probe briefing, and a UniSuper PHD review. Substantial volume — Board may wish to take a dedicated update at a future meeting.</a:t>
-            </a:r>
-          </a:p>
-        </p:txBody>
-      </p:sp>
-      <p:sp>
-        <p:nvSpPr>
-          <p:cNvPr id="8" name="TextBox 7"/>
-          <p:cNvSpPr txBox="1"/>
-          <p:nvPr/>
-        </p:nvSpPr>
-        <p:spPr>
-          <a:xfrm>
-            <a:off x="640080" y="4572000"/>
-            <a:ext cx="5394960" cy="457200"/>
+              <a:t>Civil proceedings in Ireland continuing on behalf of sixteen plaintiffs. SEC pathway active. Underpinned by 2025 evidence-base work (RJI / ARSPH merge, CRA reparations analysis).</a:t>
+            </a:r>
+          </a:p>
+        </p:txBody>
+      </p:sp>
+      <p:sp>
+        <p:nvSpPr>
+          <p:cNvPr id="11" name="TextBox 10"/>
+          <p:cNvSpPr txBox="1"/>
+          <p:nvPr/>
+        </p:nvSpPr>
+        <p:spPr>
+          <a:xfrm>
+            <a:off x="6400800" y="3657600"/>
+            <a:ext cx="5394960" cy="365760"/>
           </a:xfrm>
           <a:prstGeom prst="rect">
             <a:avLst/>
@@ -9981,27 +10303,27 @@
               </a:lnSpc>
             </a:pPr>
             <a:r>
-              <a:rPr sz="1400" b="1" i="0">
+              <a:rPr sz="1300" b="1" i="0">
                 <a:solidFill>
                   <a:srgbClr val="410F37"/>
                 </a:solidFill>
                 <a:latin typeface="Inter"/>
               </a:rPr>
-              <a:t>Meta Inc. accountability &amp; Mohib Ullah</a:t>
-            </a:r>
-          </a:p>
-        </p:txBody>
-      </p:sp>
-      <p:sp>
-        <p:nvSpPr>
-          <p:cNvPr id="9" name="TextBox 8"/>
-          <p:cNvSpPr txBox="1"/>
-          <p:nvPr/>
-        </p:nvSpPr>
-        <p:spPr>
-          <a:xfrm>
-            <a:off x="640080" y="4983480"/>
-            <a:ext cx="5394960" cy="1371600"/>
+              <a:t>Adani / UniSuper / APRA</a:t>
+            </a:r>
+          </a:p>
+        </p:txBody>
+      </p:sp>
+      <p:sp>
+        <p:nvSpPr>
+          <p:cNvPr id="12" name="TextBox 11"/>
+          <p:cNvSpPr txBox="1"/>
+          <p:nvPr/>
+        </p:nvSpPr>
+        <p:spPr>
+          <a:xfrm>
+            <a:off x="6400800" y="4023360"/>
+            <a:ext cx="5394960" cy="1280160"/>
           </a:xfrm>
           <a:prstGeom prst="rect">
             <a:avLst/>
@@ -10026,21 +10348,21 @@
                 </a:solidFill>
                 <a:latin typeface="Inter"/>
               </a:rPr>
-              <a:t>Civil proceedings in Ireland continuing on behalf of sixteen plaintiffs; SEC pathway active. Mohib Ullah submission to the UN Special Rapporteur progressed (Hashmat feedback Q1).</a:t>
-            </a:r>
-          </a:p>
-        </p:txBody>
-      </p:sp>
-      <p:sp>
-        <p:nvSpPr>
-          <p:cNvPr id="10" name="TextBox 9"/>
-          <p:cNvSpPr txBox="1"/>
-          <p:nvPr/>
-        </p:nvSpPr>
-        <p:spPr>
-          <a:xfrm>
-            <a:off x="6400800" y="1828800"/>
-            <a:ext cx="5394960" cy="457200"/>
+              <a:t>New active strand from March 2026: APRA complaint (Cbus deep-dive), Adani Investors briefings on Australian fiduciary case law and super-fund exposure to Adani / GQG, Adani Defence scoping, OFAC Iran civil-probe briefing, UniSuper PHD review.</a:t>
+            </a:r>
+          </a:p>
+        </p:txBody>
+      </p:sp>
+      <p:sp>
+        <p:nvSpPr>
+          <p:cNvPr id="13" name="TextBox 12"/>
+          <p:cNvSpPr txBox="1"/>
+          <p:nvPr/>
+        </p:nvSpPr>
+        <p:spPr>
+          <a:xfrm>
+            <a:off x="640080" y="5394960"/>
+            <a:ext cx="5394960" cy="365760"/>
           </a:xfrm>
           <a:prstGeom prst="rect">
             <a:avLst/>
@@ -10059,27 +10381,27 @@
               </a:lnSpc>
             </a:pPr>
             <a:r>
-              <a:rPr sz="1400" b="1" i="0">
+              <a:rPr sz="1300" b="1" i="0">
                 <a:solidFill>
                   <a:srgbClr val="410F37"/>
                 </a:solidFill>
                 <a:latin typeface="Inter"/>
               </a:rPr>
-              <a:t>Comms and external engagement</a:t>
-            </a:r>
-          </a:p>
-        </p:txBody>
-      </p:sp>
-      <p:sp>
-        <p:nvSpPr>
-          <p:cNvPr id="11" name="TextBox 10"/>
-          <p:cNvSpPr txBox="1"/>
-          <p:nvPr/>
-        </p:nvSpPr>
-        <p:spPr>
-          <a:xfrm>
-            <a:off x="6400800" y="2240280"/>
-            <a:ext cx="5394960" cy="1828800"/>
+              <a:t>Mohib Ullah accountability</a:t>
+            </a:r>
+          </a:p>
+        </p:txBody>
+      </p:sp>
+      <p:sp>
+        <p:nvSpPr>
+          <p:cNvPr id="14" name="TextBox 13"/>
+          <p:cNvSpPr txBox="1"/>
+          <p:nvPr/>
+        </p:nvSpPr>
+        <p:spPr>
+          <a:xfrm>
+            <a:off x="640080" y="5760720"/>
+            <a:ext cx="5394960" cy="731520"/>
           </a:xfrm>
           <a:prstGeom prst="rect">
             <a:avLst/>
@@ -10104,21 +10426,21 @@
                 </a:solidFill>
                 <a:latin typeface="Inter"/>
               </a:rPr>
-              <a:t>Frontline Club panel hosted in London (2 April) — see preceding slide. Aditi and Nazia featured-speaker videos approved end-May for onward circulation. Pitch notes drafted (April) for Rebecca Henschke (BBC World Service / BBC Eye) and Kristen Gelineau (AP). Geneva convening mid-May.</a:t>
-            </a:r>
-          </a:p>
-        </p:txBody>
-      </p:sp>
-      <p:sp>
-        <p:nvSpPr>
-          <p:cNvPr id="12" name="TextBox 11"/>
-          <p:cNvSpPr txBox="1"/>
-          <p:nvPr/>
-        </p:nvSpPr>
-        <p:spPr>
-          <a:xfrm>
-            <a:off x="6400800" y="4572000"/>
-            <a:ext cx="5394960" cy="457200"/>
+              <a:t>UN Special Rapporteur submission progressed Q1 (Hashmat feedback). ARSA designation advocacy continuing.</a:t>
+            </a:r>
+          </a:p>
+        </p:txBody>
+      </p:sp>
+      <p:sp>
+        <p:nvSpPr>
+          <p:cNvPr id="15" name="TextBox 14"/>
+          <p:cNvSpPr txBox="1"/>
+          <p:nvPr/>
+        </p:nvSpPr>
+        <p:spPr>
+          <a:xfrm>
+            <a:off x="6400800" y="5394960"/>
+            <a:ext cx="5394960" cy="365760"/>
           </a:xfrm>
           <a:prstGeom prst="rect">
             <a:avLst/>
@@ -10137,59 +10459,59 @@
               </a:lnSpc>
             </a:pPr>
             <a:r>
-              <a:rPr sz="1400" b="1" i="0">
+              <a:rPr sz="1300" b="1" i="0">
+                <a:solidFill>
+                  <a:srgbClr val="E12D64"/>
+                </a:solidFill>
+                <a:latin typeface="Inter"/>
+              </a:rPr>
+              <a:t>Note for the Board</a:t>
+            </a:r>
+          </a:p>
+        </p:txBody>
+      </p:sp>
+      <p:sp>
+        <p:nvSpPr>
+          <p:cNvPr id="16" name="TextBox 15"/>
+          <p:cNvSpPr txBox="1"/>
+          <p:nvPr/>
+        </p:nvSpPr>
+        <p:spPr>
+          <a:xfrm>
+            <a:off x="6400800" y="5760720"/>
+            <a:ext cx="5394960" cy="731520"/>
+          </a:xfrm>
+          <a:prstGeom prst="rect">
+            <a:avLst/>
+          </a:prstGeom>
+          <a:noFill/>
+        </p:spPr>
+        <p:txBody>
+          <a:bodyPr wrap="square" anchor="t" lIns="0" rIns="0" tIns="0" bIns="0">
+            <a:spAutoFit/>
+          </a:bodyPr>
+          <a:lstStyle/>
+          <a:p>
+            <a:pPr algn="l">
+              <a:lnSpc>
+                <a:spcPct val="115000"/>
+              </a:lnSpc>
+            </a:pPr>
+            <a:r>
+              <a:rPr sz="1100" b="0" i="1">
                 <a:solidFill>
                   <a:srgbClr val="410F37"/>
                 </a:solidFill>
                 <a:latin typeface="Inter"/>
               </a:rPr>
-              <a:t>Governance — Els onboarding</a:t>
-            </a:r>
-          </a:p>
-        </p:txBody>
-      </p:sp>
-      <p:sp>
-        <p:nvSpPr>
-          <p:cNvPr id="13" name="TextBox 12"/>
-          <p:cNvSpPr txBox="1"/>
-          <p:nvPr/>
-        </p:nvSpPr>
-        <p:spPr>
-          <a:xfrm>
-            <a:off x="6400800" y="4983480"/>
-            <a:ext cx="5394960" cy="1371600"/>
-          </a:xfrm>
-          <a:prstGeom prst="rect">
-            <a:avLst/>
-          </a:prstGeom>
-          <a:noFill/>
-        </p:spPr>
-        <p:txBody>
-          <a:bodyPr wrap="square" anchor="t" lIns="0" rIns="0" tIns="0" bIns="0">
-            <a:spAutoFit/>
-          </a:bodyPr>
-          <a:lstStyle/>
-          <a:p>
-            <a:pPr algn="l">
-              <a:lnSpc>
-                <a:spcPct val="115000"/>
-              </a:lnSpc>
-            </a:pPr>
-            <a:r>
-              <a:rPr sz="1100" b="0" i="0">
-                <a:solidFill>
-                  <a:srgbClr val="410F37"/>
-                </a:solidFill>
-                <a:latin typeface="Inter"/>
-              </a:rPr>
-              <a:t>Statutory director onboarding workstream completed April 2026: contracts, notary documents and statutes update, insurance cover with Els's broker. Closes Q1 action 9.</a:t>
-            </a:r>
-          </a:p>
-        </p:txBody>
-      </p:sp>
-      <p:sp>
-        <p:nvSpPr>
-          <p:cNvPr id="14" name="TextBox 13"/>
+              <a:t>Adani / UniSuper has grown enough in three months to warrant its own briefing — proposed as a dedicated paper at Q3.</a:t>
+            </a:r>
+          </a:p>
+        </p:txBody>
+      </p:sp>
+      <p:sp>
+        <p:nvSpPr>
+          <p:cNvPr id="17" name="TextBox 16"/>
           <p:cNvSpPr txBox="1"/>
           <p:nvPr/>
         </p:nvSpPr>
@@ -10228,7 +10550,7 @@
       </p:sp>
       <p:sp>
         <p:nvSpPr>
-          <p:cNvPr id="15" name="TextBox 14"/>
+          <p:cNvPr id="18" name="TextBox 17"/>
           <p:cNvSpPr txBox="1"/>
           <p:nvPr/>
         </p:nvSpPr>

</xml_diff>

<commit_message>
Brand polish pass on Q2 2026 ED Operations and Impact deck
- Replace cover and close text wordmarks with humanus Bold logo image
  (locks the brand mark regardless of installed fonts).
- Apply Fagun for headings (Bold for H2 slide titles, Medium tracked
  small-caps for section sub-heads, Black for cover/close hero).
- Keep Inter for body and tables - still the safe rendering choice
  for board members who do not have Fagun installed.
- Restyle cover meta line to Bold lime (Touch reserved for sparing
  emphasis per guidelines).
- Add PDF export so typography locks for board distribution.

Co-authored-by: multica-agent <github@multica.ai>
</commit_message>
<xml_diff>
--- a/2026/Q2/08-ED-Operations-Impact-Y2D.pptx
+++ b/2026/Q2/08-ED-Operations-Impact-Y2D.pptx
@@ -3143,45 +3143,6 @@
       </p:sp>
       <p:sp>
         <p:nvSpPr>
-          <p:cNvPr id="3" name="TextBox 2"/>
-          <p:cNvSpPr txBox="1"/>
-          <p:nvPr/>
-        </p:nvSpPr>
-        <p:spPr>
-          <a:xfrm>
-            <a:off x="0" y="2194560"/>
-            <a:ext cx="12191695" cy="914400"/>
-          </a:xfrm>
-          <a:prstGeom prst="rect">
-            <a:avLst/>
-          </a:prstGeom>
-          <a:noFill/>
-        </p:spPr>
-        <p:txBody>
-          <a:bodyPr wrap="square" anchor="t" lIns="0" rIns="0" tIns="0" bIns="0">
-            <a:spAutoFit/>
-          </a:bodyPr>
-          <a:lstStyle/>
-          <a:p>
-            <a:pPr algn="ctr">
-              <a:lnSpc>
-                <a:spcPct val="115000"/>
-              </a:lnSpc>
-            </a:pPr>
-            <a:r>
-              <a:rPr sz="8400" b="1" i="0">
-                <a:solidFill>
-                  <a:srgbClr val="96FF14"/>
-                </a:solidFill>
-                <a:latin typeface="Inter"/>
-              </a:rPr>
-              <a:t>hūmānus</a:t>
-            </a:r>
-          </a:p>
-        </p:txBody>
-      </p:sp>
-      <p:sp>
-        <p:nvSpPr>
           <p:cNvPr id="4" name="Rectangle 3"/>
           <p:cNvSpPr/>
           <p:nvPr/>
@@ -3254,9 +3215,9 @@
             <a:r>
               <a:rPr sz="1400" b="0" i="1">
                 <a:solidFill>
-                  <a:srgbClr val="E12D64"/>
-                </a:solidFill>
-                <a:latin typeface="Inter"/>
+                  <a:srgbClr val="96FF14"/>
+                </a:solidFill>
+                <a:latin typeface="Fagun Medium"/>
               </a:rPr>
               <a:t>year-to-date update  ·  Q2 2026 Board Meeting</a:t>
             </a:r>
@@ -3295,7 +3256,7 @@
                 <a:solidFill>
                   <a:srgbClr val="FFFFFF"/>
                 </a:solidFill>
-                <a:latin typeface="Inter"/>
+                <a:latin typeface="Fagun Medium"/>
               </a:rPr>
               <a:t>29 June 2026</a:t>
             </a:r>
@@ -3334,7 +3295,7 @@
                 <a:solidFill>
                   <a:srgbClr val="FFFFFF"/>
                 </a:solidFill>
-                <a:latin typeface="Inter"/>
+                <a:latin typeface="Fagun Black"/>
               </a:rPr>
               <a:t>Humanising Justice</a:t>
             </a:r>
@@ -3373,7 +3334,7 @@
                 <a:solidFill>
                   <a:srgbClr val="96FF14"/>
                 </a:solidFill>
-                <a:latin typeface="Inter"/>
+                <a:latin typeface="Fagun Medium"/>
               </a:rPr>
               <a:t>ACCOUNTABILITY  ·  COMMUNITY  ·  EVIDENCE</a:t>
             </a:r>
@@ -3419,6 +3380,30 @@
           </a:p>
         </p:txBody>
       </p:sp>
+      <p:pic>
+        <p:nvPicPr>
+          <p:cNvPr id="10" name="Picture 9" descr="humanus_logo_master_bold.png"/>
+          <p:cNvPicPr>
+            <a:picLocks noChangeAspect="1"/>
+          </p:cNvPicPr>
+          <p:nvPr/>
+        </p:nvPicPr>
+        <p:blipFill>
+          <a:blip r:embed="rId2"/>
+          <a:stretch>
+            <a:fillRect/>
+          </a:stretch>
+        </p:blipFill>
+        <p:spPr>
+          <a:xfrm>
+            <a:off x="1341086" y="1011143"/>
+            <a:ext cx="9509522" cy="3281234"/>
+          </a:xfrm>
+          <a:prstGeom prst="rect">
+            <a:avLst/>
+          </a:prstGeom>
+        </p:spPr>
+      </p:pic>
     </p:spTree>
   </p:cSld>
   <p:clrMapOvr>
@@ -3512,7 +3497,7 @@
                 <a:solidFill>
                   <a:srgbClr val="410F37"/>
                 </a:solidFill>
-                <a:latin typeface="Inter"/>
+                <a:latin typeface="Fagun Bold"/>
               </a:rPr>
               <a:t>Strategic outlook and watch-items</a:t>
             </a:r>
@@ -3678,7 +3663,7 @@
                 <a:solidFill>
                   <a:srgbClr val="410F37"/>
                 </a:solidFill>
-                <a:latin typeface="Inter"/>
+                <a:latin typeface="Fagun Bold"/>
               </a:rPr>
               <a:t>Reserves and deficit-model donors</a:t>
             </a:r>
@@ -3800,7 +3785,7 @@
                 <a:solidFill>
                   <a:srgbClr val="410F37"/>
                 </a:solidFill>
-                <a:latin typeface="Inter"/>
+                <a:latin typeface="Fagun Bold"/>
               </a:rPr>
               <a:t>VAI ↔ hūmānus entity transition</a:t>
             </a:r>
@@ -3922,7 +3907,7 @@
                 <a:solidFill>
                   <a:srgbClr val="410F37"/>
                 </a:solidFill>
-                <a:latin typeface="Inter"/>
+                <a:latin typeface="Fagun Bold"/>
               </a:rPr>
               <a:t>Bangladesh operating environment</a:t>
             </a:r>
@@ -4044,7 +4029,7 @@
                 <a:solidFill>
                   <a:srgbClr val="410F37"/>
                 </a:solidFill>
-                <a:latin typeface="Inter"/>
+                <a:latin typeface="Fagun Bold"/>
               </a:rPr>
               <a:t>Beyond 2029 / post-OSF horizon</a:t>
             </a:r>
@@ -4166,7 +4151,7 @@
                 <a:solidFill>
                   <a:srgbClr val="410F37"/>
                 </a:solidFill>
-                <a:latin typeface="Inter"/>
+                <a:latin typeface="Fagun Bold"/>
               </a:rPr>
               <a:t>Hiring posture</a:t>
             </a:r>
@@ -4288,7 +4273,7 @@
                 <a:solidFill>
                   <a:srgbClr val="410F37"/>
                 </a:solidFill>
-                <a:latin typeface="Inter"/>
+                <a:latin typeface="Fagun Bold"/>
               </a:rPr>
               <a:t>Governance and external engagement</a:t>
             </a:r>
@@ -4475,45 +4460,6 @@
       </p:sp>
       <p:sp>
         <p:nvSpPr>
-          <p:cNvPr id="3" name="TextBox 2"/>
-          <p:cNvSpPr txBox="1"/>
-          <p:nvPr/>
-        </p:nvSpPr>
-        <p:spPr>
-          <a:xfrm>
-            <a:off x="0" y="2194560"/>
-            <a:ext cx="12191695" cy="914400"/>
-          </a:xfrm>
-          <a:prstGeom prst="rect">
-            <a:avLst/>
-          </a:prstGeom>
-          <a:noFill/>
-        </p:spPr>
-        <p:txBody>
-          <a:bodyPr wrap="square" anchor="t" lIns="0" rIns="0" tIns="0" bIns="0">
-            <a:spAutoFit/>
-          </a:bodyPr>
-          <a:lstStyle/>
-          <a:p>
-            <a:pPr algn="ctr">
-              <a:lnSpc>
-                <a:spcPct val="115000"/>
-              </a:lnSpc>
-            </a:pPr>
-            <a:r>
-              <a:rPr sz="6400" b="1" i="0">
-                <a:solidFill>
-                  <a:srgbClr val="96FF14"/>
-                </a:solidFill>
-                <a:latin typeface="Inter"/>
-              </a:rPr>
-              <a:t>hūmānus</a:t>
-            </a:r>
-          </a:p>
-        </p:txBody>
-      </p:sp>
-      <p:sp>
-        <p:nvSpPr>
           <p:cNvPr id="4" name="TextBox 3"/>
           <p:cNvSpPr txBox="1"/>
           <p:nvPr/>
@@ -4544,7 +4490,7 @@
                 <a:solidFill>
                   <a:srgbClr val="FFFFFF"/>
                 </a:solidFill>
-                <a:latin typeface="Inter"/>
+                <a:latin typeface="Fagun Black"/>
               </a:rPr>
               <a:t>Humanising justice</a:t>
             </a:r>
@@ -4583,7 +4529,7 @@
                 <a:solidFill>
                   <a:srgbClr val="96FF14"/>
                 </a:solidFill>
-                <a:latin typeface="Inter"/>
+                <a:latin typeface="Fagun Medium"/>
               </a:rPr>
               <a:t>ACCOUNTABILITY  ·  COMMUNITY  ·  EVIDENCE</a:t>
             </a:r>
@@ -4668,6 +4614,30 @@
           </a:p>
         </p:txBody>
       </p:sp>
+      <p:pic>
+        <p:nvPicPr>
+          <p:cNvPr id="8" name="Picture 7" descr="humanus_logo_master_bold.png"/>
+          <p:cNvPicPr>
+            <a:picLocks noChangeAspect="1"/>
+          </p:cNvPicPr>
+          <p:nvPr/>
+        </p:nvPicPr>
+        <p:blipFill>
+          <a:blip r:embed="rId2"/>
+          <a:stretch>
+            <a:fillRect/>
+          </a:stretch>
+        </p:blipFill>
+        <p:spPr>
+          <a:xfrm>
+            <a:off x="1341086" y="1011143"/>
+            <a:ext cx="9509522" cy="3281234"/>
+          </a:xfrm>
+          <a:prstGeom prst="rect">
+            <a:avLst/>
+          </a:prstGeom>
+        </p:spPr>
+      </p:pic>
     </p:spTree>
   </p:cSld>
   <p:clrMapOvr>
@@ -4761,7 +4731,7 @@
                 <a:solidFill>
                   <a:srgbClr val="410F37"/>
                 </a:solidFill>
-                <a:latin typeface="Inter"/>
+                <a:latin typeface="Fagun Bold"/>
               </a:rPr>
               <a:t>Three goals guide everything we do</a:t>
             </a:r>
@@ -4927,7 +4897,7 @@
                 <a:solidFill>
                   <a:srgbClr val="96FF14"/>
                 </a:solidFill>
-                <a:latin typeface="Inter"/>
+                <a:latin typeface="Fagun Black"/>
               </a:rPr>
               <a:t>1</a:t>
             </a:r>
@@ -5049,7 +5019,7 @@
                 <a:solidFill>
                   <a:srgbClr val="96FF14"/>
                 </a:solidFill>
-                <a:latin typeface="Inter"/>
+                <a:latin typeface="Fagun Black"/>
               </a:rPr>
               <a:t>2</a:t>
             </a:r>
@@ -5171,7 +5141,7 @@
                 <a:solidFill>
                   <a:srgbClr val="96FF14"/>
                 </a:solidFill>
-                <a:latin typeface="Inter"/>
+                <a:latin typeface="Fagun Black"/>
               </a:rPr>
               <a:t>3</a:t>
             </a:r>
@@ -5427,7 +5397,7 @@
                 <a:solidFill>
                   <a:srgbClr val="410F37"/>
                 </a:solidFill>
-                <a:latin typeface="Inter"/>
+                <a:latin typeface="Fagun Bold"/>
               </a:rPr>
               <a:t>Where the work has sat this year</a:t>
             </a:r>
@@ -5754,7 +5724,7 @@
                 <a:solidFill>
                   <a:srgbClr val="410F37"/>
                 </a:solidFill>
-                <a:latin typeface="Inter"/>
+                <a:latin typeface="Fagun Bold"/>
               </a:rPr>
               <a:t>Towards a More Peaceful Arakan</a:t>
             </a:r>
@@ -6076,7 +6046,7 @@
                 <a:solidFill>
                   <a:srgbClr val="410F37"/>
                 </a:solidFill>
-                <a:latin typeface="Inter"/>
+                <a:latin typeface="Fagun Bold"/>
               </a:rPr>
               <a:t>Rohingya in India — legal protection</a:t>
             </a:r>
@@ -6398,7 +6368,7 @@
                 <a:solidFill>
                   <a:srgbClr val="410F37"/>
                 </a:solidFill>
-                <a:latin typeface="Inter"/>
+                <a:latin typeface="Fagun Bold"/>
               </a:rPr>
               <a:t>Accountability for business and human rights</a:t>
             </a:r>
@@ -6854,7 +6824,7 @@
                 <a:solidFill>
                   <a:srgbClr val="410F37"/>
                 </a:solidFill>
-                <a:latin typeface="Inter"/>
+                <a:latin typeface="Fagun Bold"/>
               </a:rPr>
               <a:t>Towards a More Peaceful Arakan</a:t>
             </a:r>
@@ -6972,13 +6942,13 @@
               </a:lnSpc>
             </a:pPr>
             <a:r>
-              <a:rPr sz="1500" b="1" i="0">
+              <a:rPr sz="1500" b="0" i="0">
                 <a:solidFill>
                   <a:srgbClr val="410F37"/>
                 </a:solidFill>
-                <a:latin typeface="Inter"/>
-              </a:rPr>
-              <a:t>What the project is</a:t>
+                <a:latin typeface="Fagun Medium"/>
+              </a:rPr>
+              <a:t>WHAT THE PROJECT IS</a:t>
             </a:r>
           </a:p>
         </p:txBody>
@@ -7050,13 +7020,13 @@
               </a:lnSpc>
             </a:pPr>
             <a:r>
-              <a:rPr sz="1500" b="1" i="0">
+              <a:rPr sz="1500" b="0" i="0">
                 <a:solidFill>
                   <a:srgbClr val="410F37"/>
                 </a:solidFill>
-                <a:latin typeface="Inter"/>
-              </a:rPr>
-              <a:t>Where we are</a:t>
+                <a:latin typeface="Fagun Medium"/>
+              </a:rPr>
+              <a:t>WHERE WE ARE</a:t>
             </a:r>
           </a:p>
         </p:txBody>
@@ -7481,7 +7451,7 @@
                 <a:solidFill>
                   <a:srgbClr val="410F37"/>
                 </a:solidFill>
-                <a:latin typeface="Inter"/>
+                <a:latin typeface="Fagun Bold"/>
               </a:rPr>
               <a:t>Bangladesh dialogue programme</a:t>
             </a:r>
@@ -7599,13 +7569,13 @@
               </a:lnSpc>
             </a:pPr>
             <a:r>
-              <a:rPr sz="1500" b="1" i="0">
+              <a:rPr sz="1500" b="0" i="0">
                 <a:solidFill>
                   <a:srgbClr val="410F37"/>
                 </a:solidFill>
-                <a:latin typeface="Inter"/>
-              </a:rPr>
-              <a:t>What the funding supports</a:t>
+                <a:latin typeface="Fagun Medium"/>
+              </a:rPr>
+              <a:t>WHAT THE FUNDING SUPPORTS</a:t>
             </a:r>
           </a:p>
         </p:txBody>
@@ -7677,13 +7647,13 @@
               </a:lnSpc>
             </a:pPr>
             <a:r>
-              <a:rPr sz="1500" b="1" i="0">
+              <a:rPr sz="1500" b="0" i="0">
                 <a:solidFill>
                   <a:srgbClr val="410F37"/>
                 </a:solidFill>
-                <a:latin typeface="Inter"/>
-              </a:rPr>
-              <a:t>Where we are</a:t>
+                <a:latin typeface="Fagun Medium"/>
+              </a:rPr>
+              <a:t>WHERE WE ARE</a:t>
             </a:r>
           </a:p>
         </p:txBody>
@@ -8108,7 +8078,7 @@
                 <a:solidFill>
                   <a:srgbClr val="410F37"/>
                 </a:solidFill>
-                <a:latin typeface="Inter"/>
+                <a:latin typeface="Fagun Bold"/>
               </a:rPr>
               <a:t>Rohingya in India — legal protection</a:t>
             </a:r>
@@ -8226,13 +8196,13 @@
               </a:lnSpc>
             </a:pPr>
             <a:r>
-              <a:rPr sz="1500" b="1" i="0">
+              <a:rPr sz="1500" b="0" i="0">
                 <a:solidFill>
                   <a:srgbClr val="410F37"/>
                 </a:solidFill>
-                <a:latin typeface="Inter"/>
-              </a:rPr>
-              <a:t>What the strand is</a:t>
+                <a:latin typeface="Fagun Medium"/>
+              </a:rPr>
+              <a:t>WHAT THE STRAND IS</a:t>
             </a:r>
           </a:p>
         </p:txBody>
@@ -8304,13 +8274,13 @@
               </a:lnSpc>
             </a:pPr>
             <a:r>
-              <a:rPr sz="1500" b="1" i="0">
+              <a:rPr sz="1500" b="0" i="0">
                 <a:solidFill>
                   <a:srgbClr val="410F37"/>
                 </a:solidFill>
-                <a:latin typeface="Inter"/>
-              </a:rPr>
-              <a:t>Y2D streams</a:t>
+                <a:latin typeface="Fagun Medium"/>
+              </a:rPr>
+              <a:t>Y2D STREAMS</a:t>
             </a:r>
           </a:p>
         </p:txBody>
@@ -8901,7 +8871,7 @@
                 <a:solidFill>
                   <a:srgbClr val="410F37"/>
                 </a:solidFill>
-                <a:latin typeface="Inter"/>
+                <a:latin typeface="Fagun Bold"/>
               </a:rPr>
               <a:t>Women's Dialogue — grant close-out</a:t>
             </a:r>
@@ -9019,13 +8989,13 @@
               </a:lnSpc>
             </a:pPr>
             <a:r>
-              <a:rPr sz="1500" b="1" i="0">
+              <a:rPr sz="1500" b="0" i="0">
                 <a:solidFill>
                   <a:srgbClr val="410F37"/>
                 </a:solidFill>
-                <a:latin typeface="Inter"/>
-              </a:rPr>
-              <a:t>Where the work has sat in 2026</a:t>
+                <a:latin typeface="Fagun Medium"/>
+              </a:rPr>
+              <a:t>WHERE THE WORK HAS SAT IN 2026</a:t>
             </a:r>
           </a:p>
         </p:txBody>
@@ -9307,13 +9277,13 @@
               </a:lnSpc>
             </a:pPr>
             <a:r>
-              <a:rPr sz="1400" b="1" i="0">
-                <a:solidFill>
-                  <a:srgbClr val="E12D64"/>
-                </a:solidFill>
-                <a:latin typeface="Inter"/>
-              </a:rPr>
-              <a:t>Why this matters for the Board</a:t>
+              <a:rPr sz="1400" b="0" i="0">
+                <a:solidFill>
+                  <a:srgbClr val="410F37"/>
+                </a:solidFill>
+                <a:latin typeface="Fagun Medium"/>
+              </a:rPr>
+              <a:t>WHY THIS MATTERS FOR THE BOARD</a:t>
             </a:r>
           </a:p>
         </p:txBody>
@@ -9596,7 +9566,7 @@
                 <a:solidFill>
                   <a:srgbClr val="96FF14"/>
                 </a:solidFill>
-                <a:latin typeface="Inter"/>
+                <a:latin typeface="Fagun Medium"/>
               </a:rPr>
               <a:t>PUBLIC ENGAGEMENT</a:t>
             </a:r>
@@ -9635,7 +9605,7 @@
                 <a:solidFill>
                   <a:srgbClr val="FFFFFF"/>
                 </a:solidFill>
-                <a:latin typeface="Inter"/>
+                <a:latin typeface="Fagun Black"/>
               </a:rPr>
               <a:t>Frontline Club</a:t>
             </a:r>
@@ -9651,7 +9621,7 @@
                 <a:solidFill>
                   <a:srgbClr val="FFFFFF"/>
                 </a:solidFill>
-                <a:latin typeface="Inter"/>
+                <a:latin typeface="Fagun Black"/>
               </a:rPr>
               <a:t>panel — London</a:t>
             </a:r>
@@ -9734,7 +9704,7 @@
                 <a:solidFill>
                   <a:srgbClr val="96FF14"/>
                 </a:solidFill>
-                <a:latin typeface="Inter"/>
+                <a:latin typeface="Fagun Medium"/>
               </a:rPr>
               <a:t>Human Rights in a Fragmenting World</a:t>
             </a:r>
@@ -9773,7 +9743,7 @@
                 <a:solidFill>
                   <a:srgbClr val="FFFFFF"/>
                 </a:solidFill>
-                <a:latin typeface="Inter"/>
+                <a:latin typeface="Fagun Medium"/>
               </a:rPr>
               <a:t>2 April 2026</a:t>
             </a:r>
@@ -9990,7 +9960,7 @@
                 <a:solidFill>
                   <a:srgbClr val="410F37"/>
                 </a:solidFill>
-                <a:latin typeface="Inter"/>
+                <a:latin typeface="Fagun Bold"/>
               </a:rPr>
               <a:t>Accountability for business and human rights</a:t>
             </a:r>
@@ -10108,13 +10078,13 @@
               </a:lnSpc>
             </a:pPr>
             <a:r>
-              <a:rPr sz="1500" b="1" i="0">
+              <a:rPr sz="1500" b="0" i="0">
                 <a:solidFill>
                   <a:srgbClr val="410F37"/>
                 </a:solidFill>
-                <a:latin typeface="Inter"/>
-              </a:rPr>
-              <a:t>The framework</a:t>
+                <a:latin typeface="Fagun Medium"/>
+              </a:rPr>
+              <a:t>THE FRAMEWORK</a:t>
             </a:r>
           </a:p>
         </p:txBody>
@@ -10186,13 +10156,13 @@
               </a:lnSpc>
             </a:pPr>
             <a:r>
-              <a:rPr sz="1500" b="1" i="0">
+              <a:rPr sz="1500" b="0" i="0">
                 <a:solidFill>
                   <a:srgbClr val="410F37"/>
                 </a:solidFill>
-                <a:latin typeface="Inter"/>
-              </a:rPr>
-              <a:t>Active workstreams</a:t>
+                <a:latin typeface="Fagun Medium"/>
+              </a:rPr>
+              <a:t>ACTIVE WORKSTREAMS</a:t>
             </a:r>
           </a:p>
         </p:txBody>
@@ -10229,7 +10199,7 @@
                 <a:solidFill>
                   <a:srgbClr val="410F37"/>
                 </a:solidFill>
-                <a:latin typeface="Inter"/>
+                <a:latin typeface="Fagun Bold"/>
               </a:rPr>
               <a:t>Meta Inc.</a:t>
             </a:r>
@@ -10307,7 +10277,7 @@
                 <a:solidFill>
                   <a:srgbClr val="410F37"/>
                 </a:solidFill>
-                <a:latin typeface="Inter"/>
+                <a:latin typeface="Fagun Bold"/>
               </a:rPr>
               <a:t>Adani / UniSuper / APRA</a:t>
             </a:r>
@@ -10385,7 +10355,7 @@
                 <a:solidFill>
                   <a:srgbClr val="410F37"/>
                 </a:solidFill>
-                <a:latin typeface="Inter"/>
+                <a:latin typeface="Fagun Bold"/>
               </a:rPr>
               <a:t>Mohib Ullah accountability</a:t>
             </a:r>
@@ -10461,9 +10431,9 @@
             <a:r>
               <a:rPr sz="1300" b="1" i="0">
                 <a:solidFill>
-                  <a:srgbClr val="E12D64"/>
-                </a:solidFill>
-                <a:latin typeface="Inter"/>
+                  <a:srgbClr val="410F37"/>
+                </a:solidFill>
+                <a:latin typeface="Fagun Bold"/>
               </a:rPr>
               <a:t>Note for the Board</a:t>
             </a:r>

</xml_diff>